<commit_message>
Phase 1 PACE Accuracy Deepening + Prospectus Builder System
- Database migration: Add prospectus_documents, prospectus_sections, document_section_mappings tables
- Prospectus extraction: PDF/DOCX/CSV/text support with keyword + frequency confidence scoring
- Prospectus mapper: Levenshtein distance algorithm with 3-tier automation (auto_fill/review/manual)
- PACE improvements: Real IPO benchmarking, predictive factors, milestone sequencing, document completeness
- PACE UI components: ReadinessFactorsCard, ConfidenceBadge, SequenceAlertsSection, DocumentReadinessCard
- Prospectus builder API: POST /api/prospectus/[id]/extract with full mapping pipeline
- Prospectus editor: Page to manage extracted sections with drag-drop and bulk operations
</commit_message>
<xml_diff>
--- a/IPOReady_LinkedIn_Campaign.pptx
+++ b/IPOReady_LinkedIn_Campaign.pptx
@@ -15,8 +15,8 @@
   <p:notesMasterIdLst>
     <p:notesMasterId r:id="rId8"/>
   </p:notesMasterIdLst>
-  <p:sldSz cx="9144000" cy="11430000"/>
-  <p:notesSz cx="11430000" cy="9144000"/>
+  <p:sldSz cx="9144000" cy="5143500"/>
+  <p:notesSz cx="5143500" cy="9144000"/>
   <p:defaultTextStyle>
     <a:lvl1pPr marL="0" algn="l" defTabSz="914400" rtl="0" eaLnBrk="1" latinLnBrk="0" hangingPunct="1">
       <a:defRPr sz="1800" kern="1200">
@@ -1328,31 +1328,34 @@
         </p:nvSpPr>
         <p:spPr>
           <a:xfrm>
-            <a:off x="4114800" y="274320"/>
-            <a:ext cx="914400" cy="548640"/>
-          </a:xfrm>
-          <a:prstGeom prst="rect">
-            <a:avLst/>
-          </a:prstGeom>
-          <a:noFill/>
-          <a:ln/>
-        </p:spPr>
-        <p:txBody>
-          <a:bodyPr wrap="square" rtlCol="0" anchor="ctr"/>
-          <a:lstStyle/>
-          <a:p>
-            <a:pPr algn="ctr" indent="0" marL="0">
-              <a:buNone/>
-            </a:pPr>
-            <a:r>
-              <a:rPr lang="en-US" sz="4800" dirty="0">
-                <a:solidFill>
-                  <a:srgbClr val="000000"/>
-                </a:solidFill>
-              </a:rPr>
-              <a:t>🚨</a:t>
-            </a:r>
-            <a:endParaRPr lang="en-US" sz="4800" dirty="0"/>
+            <a:off x="457200" y="1371600"/>
+            <a:ext cx="8842248" cy="1097280"/>
+          </a:xfrm>
+          <a:prstGeom prst="rect">
+            <a:avLst/>
+          </a:prstGeom>
+          <a:noFill/>
+          <a:ln/>
+        </p:spPr>
+        <p:txBody>
+          <a:bodyPr wrap="square" rtlCol="0" anchor="ctr"/>
+          <a:lstStyle/>
+          <a:p>
+            <a:pPr algn="ctr" indent="0" marL="0">
+              <a:buNone/>
+            </a:pPr>
+            <a:r>
+              <a:rPr lang="en-US" sz="5600" b="1" dirty="0">
+                <a:solidFill>
+                  <a:srgbClr val="FFFFFF"/>
+                </a:solidFill>
+                <a:latin typeface="Arial" pitchFamily="34" charset="0"/>
+                <a:ea typeface="Arial" pitchFamily="34" charset="-122"/>
+                <a:cs typeface="Arial" pitchFamily="34" charset="-120"/>
+              </a:rPr>
+              <a:t>The IPO Readiness Engine</a:t>
+            </a:r>
+            <a:endParaRPr lang="en-US" sz="5600" dirty="0"/>
           </a:p>
         </p:txBody>
       </p:sp>
@@ -1364,67 +1367,224 @@
         </p:nvSpPr>
         <p:spPr>
           <a:xfrm>
-            <a:off x="457200" y="1097280"/>
-            <a:ext cx="8229600" cy="1645920"/>
-          </a:xfrm>
-          <a:prstGeom prst="rect">
-            <a:avLst/>
-          </a:prstGeom>
-          <a:noFill/>
-          <a:ln/>
-        </p:spPr>
-        <p:txBody>
-          <a:bodyPr wrap="square" rtlCol="0" anchor="t"/>
-          <a:lstStyle/>
-          <a:p>
-            <a:pPr algn="ctr" indent="0" marL="0">
-              <a:buNone/>
-            </a:pPr>
-            <a:r>
-              <a:rPr lang="en-US" sz="3600" b="1" dirty="0">
-                <a:solidFill>
-                  <a:srgbClr val="FFFFFF"/>
-                </a:solidFill>
-              </a:rPr>
-              <a:t>The IPO Readiness Problem No One Is Solving</a:t>
-            </a:r>
-            <a:endParaRPr lang="en-US" sz="3600" dirty="0"/>
-          </a:p>
-        </p:txBody>
-      </p:sp>
-      <p:sp>
-        <p:nvSpPr>
-          <p:cNvPr id="4" name="Text 2"/>
-          <p:cNvSpPr/>
-          <p:nvPr/>
-        </p:nvSpPr>
-        <p:spPr>
-          <a:xfrm>
-            <a:off x="457200" y="10789920"/>
-            <a:ext cx="8229600" cy="365760"/>
-          </a:xfrm>
-          <a:prstGeom prst="rect">
-            <a:avLst/>
-          </a:prstGeom>
-          <a:noFill/>
-          <a:ln/>
-        </p:spPr>
-        <p:txBody>
-          <a:bodyPr wrap="square" rtlCol="0" anchor="ctr"/>
-          <a:lstStyle/>
-          <a:p>
-            <a:pPr algn="ctr" indent="0" marL="0">
-              <a:buNone/>
-            </a:pPr>
-            <a:r>
-              <a:rPr lang="en-US" sz="1100" i="1" dirty="0">
-                <a:solidFill>
-                  <a:srgbClr val="FFFFFF"/>
-                </a:solidFill>
-              </a:rPr>
-              <a:t>LinkedIn Post 1</a:t>
-            </a:r>
-            <a:endParaRPr lang="en-US" sz="1100" dirty="0"/>
+            <a:off x="457200" y="2560320"/>
+            <a:ext cx="8842248" cy="731520"/>
+          </a:xfrm>
+          <a:prstGeom prst="rect">
+            <a:avLst/>
+          </a:prstGeom>
+          <a:noFill/>
+          <a:ln/>
+        </p:spPr>
+        <p:txBody>
+          <a:bodyPr wrap="square" rtlCol="0" anchor="ctr"/>
+          <a:lstStyle/>
+          <a:p>
+            <a:pPr algn="ctr" indent="0" marL="0">
+              <a:buNone/>
+            </a:pPr>
+            <a:r>
+              <a:rPr lang="en-US" sz="3200" dirty="0">
+                <a:solidFill>
+                  <a:srgbClr val="F9E795"/>
+                </a:solidFill>
+                <a:latin typeface="Arial" pitchFamily="34" charset="0"/>
+                <a:ea typeface="Arial" pitchFamily="34" charset="-122"/>
+                <a:cs typeface="Arial" pitchFamily="34" charset="-120"/>
+              </a:rPr>
+              <a:t>Meet PACE™: Your compass to IPO success</a:t>
+            </a:r>
+            <a:endParaRPr lang="en-US" sz="3200" dirty="0"/>
+          </a:p>
+        </p:txBody>
+      </p:sp>
+      <p:sp>
+        <p:nvSpPr>
+          <p:cNvPr id="4" name="Shape 2"/>
+          <p:cNvSpPr/>
+          <p:nvPr/>
+        </p:nvSpPr>
+        <p:spPr>
+          <a:xfrm>
+            <a:off x="2743200" y="3840480"/>
+            <a:ext cx="4270248" cy="731520"/>
+          </a:xfrm>
+          <a:prstGeom prst="rect">
+            <a:avLst/>
+          </a:prstGeom>
+          <a:solidFill>
+            <a:srgbClr val="F96167"/>
+          </a:solidFill>
+          <a:ln/>
+        </p:spPr>
+      </p:sp>
+      <p:sp>
+        <p:nvSpPr>
+          <p:cNvPr id="5" name="Text 3"/>
+          <p:cNvSpPr/>
+          <p:nvPr/>
+        </p:nvSpPr>
+        <p:spPr>
+          <a:xfrm>
+            <a:off x="2743200" y="3840480"/>
+            <a:ext cx="4270248" cy="731520"/>
+          </a:xfrm>
+          <a:prstGeom prst="rect">
+            <a:avLst/>
+          </a:prstGeom>
+          <a:noFill/>
+          <a:ln/>
+        </p:spPr>
+        <p:txBody>
+          <a:bodyPr wrap="square" rtlCol="0" anchor="ctr"/>
+          <a:lstStyle/>
+          <a:p>
+            <a:pPr algn="ctr" indent="0" marL="0">
+              <a:buNone/>
+            </a:pPr>
+            <a:r>
+              <a:rPr lang="en-US" sz="2000" b="1" dirty="0">
+                <a:solidFill>
+                  <a:srgbClr val="FFFFFF"/>
+                </a:solidFill>
+              </a:rPr>
+              <a:t>Powered by Real IPO Data</a:t>
+            </a:r>
+            <a:endParaRPr lang="en-US" sz="2000" dirty="0"/>
+          </a:p>
+        </p:txBody>
+      </p:sp>
+      <p:sp>
+        <p:nvSpPr>
+          <p:cNvPr id="6" name="Text 4"/>
+          <p:cNvSpPr/>
+          <p:nvPr/>
+        </p:nvSpPr>
+        <p:spPr>
+          <a:xfrm>
+            <a:off x="457200" y="1371600"/>
+            <a:ext cx="8842248" cy="1097280"/>
+          </a:xfrm>
+          <a:prstGeom prst="rect">
+            <a:avLst/>
+          </a:prstGeom>
+          <a:noFill/>
+          <a:ln/>
+        </p:spPr>
+        <p:txBody>
+          <a:bodyPr wrap="square" rtlCol="0" anchor="ctr"/>
+          <a:lstStyle/>
+          <a:p>
+            <a:pPr algn="ctr" indent="0" marL="0">
+              <a:buNone/>
+            </a:pPr>
+            <a:r>
+              <a:rPr lang="en-US" sz="5600" b="1" dirty="0">
+                <a:solidFill>
+                  <a:srgbClr val="FFFFFF"/>
+                </a:solidFill>
+                <a:latin typeface="Arial" pitchFamily="34" charset="0"/>
+                <a:ea typeface="Arial" pitchFamily="34" charset="-122"/>
+                <a:cs typeface="Arial" pitchFamily="34" charset="-120"/>
+              </a:rPr>
+              <a:t>The IPO Readiness Engine</a:t>
+            </a:r>
+            <a:endParaRPr lang="en-US" sz="5600" dirty="0"/>
+          </a:p>
+        </p:txBody>
+      </p:sp>
+      <p:sp>
+        <p:nvSpPr>
+          <p:cNvPr id="7" name="Text 5"/>
+          <p:cNvSpPr/>
+          <p:nvPr/>
+        </p:nvSpPr>
+        <p:spPr>
+          <a:xfrm>
+            <a:off x="457200" y="2560320"/>
+            <a:ext cx="8842248" cy="731520"/>
+          </a:xfrm>
+          <a:prstGeom prst="rect">
+            <a:avLst/>
+          </a:prstGeom>
+          <a:noFill/>
+          <a:ln/>
+        </p:spPr>
+        <p:txBody>
+          <a:bodyPr wrap="square" rtlCol="0" anchor="ctr"/>
+          <a:lstStyle/>
+          <a:p>
+            <a:pPr algn="ctr" indent="0" marL="0">
+              <a:buNone/>
+            </a:pPr>
+            <a:r>
+              <a:rPr lang="en-US" sz="3200" dirty="0">
+                <a:solidFill>
+                  <a:srgbClr val="F9E795"/>
+                </a:solidFill>
+                <a:latin typeface="Arial" pitchFamily="34" charset="0"/>
+                <a:ea typeface="Arial" pitchFamily="34" charset="-122"/>
+                <a:cs typeface="Arial" pitchFamily="34" charset="-120"/>
+              </a:rPr>
+              <a:t>Meet PACE: Your compass to IPO success</a:t>
+            </a:r>
+            <a:endParaRPr lang="en-US" sz="3200" dirty="0"/>
+          </a:p>
+        </p:txBody>
+      </p:sp>
+      <p:sp>
+        <p:nvSpPr>
+          <p:cNvPr id="8" name="Shape 6"/>
+          <p:cNvSpPr/>
+          <p:nvPr/>
+        </p:nvSpPr>
+        <p:spPr>
+          <a:xfrm>
+            <a:off x="2743200" y="3840480"/>
+            <a:ext cx="4270248" cy="731520"/>
+          </a:xfrm>
+          <a:prstGeom prst="rect">
+            <a:avLst/>
+          </a:prstGeom>
+          <a:solidFill>
+            <a:srgbClr val="F96167"/>
+          </a:solidFill>
+          <a:ln/>
+        </p:spPr>
+      </p:sp>
+      <p:sp>
+        <p:nvSpPr>
+          <p:cNvPr id="9" name="Text 7"/>
+          <p:cNvSpPr/>
+          <p:nvPr/>
+        </p:nvSpPr>
+        <p:spPr>
+          <a:xfrm>
+            <a:off x="2743200" y="3840480"/>
+            <a:ext cx="4270248" cy="731520"/>
+          </a:xfrm>
+          <a:prstGeom prst="rect">
+            <a:avLst/>
+          </a:prstGeom>
+          <a:noFill/>
+          <a:ln/>
+        </p:spPr>
+        <p:txBody>
+          <a:bodyPr wrap="square" rtlCol="0" anchor="ctr"/>
+          <a:lstStyle/>
+          <a:p>
+            <a:pPr algn="ctr" indent="0" marL="0">
+              <a:buNone/>
+            </a:pPr>
+            <a:r>
+              <a:rPr lang="en-US" sz="2000" b="1" dirty="0">
+                <a:solidFill>
+                  <a:srgbClr val="FFFFFF"/>
+                </a:solidFill>
+              </a:rPr>
+              <a:t>Powered by Real IPO Data</a:t>
+            </a:r>
+            <a:endParaRPr lang="en-US" sz="2000" dirty="0"/>
           </a:p>
         </p:txBody>
       </p:sp>
@@ -1439,146 +1599,6 @@
 <file path=ppt/slides/slide2.xml><?xml version="1.0" encoding="utf-8"?>
 <p:sld xmlns:a="http://schemas.openxmlformats.org/drawingml/2006/main" xmlns:r="http://schemas.openxmlformats.org/officeDocument/2006/relationships" xmlns:p="http://schemas.openxmlformats.org/presentationml/2006/main">
   <p:cSld name="Slide 2">
-    <p:bg>
-      <p:bgPr>
-        <a:solidFill>
-          <a:srgbClr val="028090"/>
-        </a:solidFill>
-      </p:bgPr>
-    </p:bg>
-    <p:spTree>
-      <p:nvGrpSpPr>
-        <p:cNvPr id="1" name=""/>
-        <p:cNvGrpSpPr/>
-        <p:nvPr/>
-      </p:nvGrpSpPr>
-      <p:grpSpPr>
-        <a:xfrm>
-          <a:off x="0" y="0"/>
-          <a:ext cx="0" cy="0"/>
-          <a:chOff x="0" y="0"/>
-          <a:chExt cx="0" cy="0"/>
-        </a:xfrm>
-      </p:grpSpPr>
-      <p:sp>
-        <p:nvSpPr>
-          <p:cNvPr id="2" name="Text 0"/>
-          <p:cNvSpPr/>
-          <p:nvPr/>
-        </p:nvSpPr>
-        <p:spPr>
-          <a:xfrm>
-            <a:off x="4114800" y="274320"/>
-            <a:ext cx="914400" cy="548640"/>
-          </a:xfrm>
-          <a:prstGeom prst="rect">
-            <a:avLst/>
-          </a:prstGeom>
-          <a:noFill/>
-          <a:ln/>
-        </p:spPr>
-        <p:txBody>
-          <a:bodyPr wrap="square" rtlCol="0" anchor="ctr"/>
-          <a:lstStyle/>
-          <a:p>
-            <a:pPr algn="ctr" indent="0" marL="0">
-              <a:buNone/>
-            </a:pPr>
-            <a:r>
-              <a:rPr lang="en-US" sz="4800" dirty="0">
-                <a:solidFill>
-                  <a:srgbClr val="000000"/>
-                </a:solidFill>
-              </a:rPr>
-              <a:t>🎯</a:t>
-            </a:r>
-            <a:endParaRPr lang="en-US" sz="4800" dirty="0"/>
-          </a:p>
-        </p:txBody>
-      </p:sp>
-      <p:sp>
-        <p:nvSpPr>
-          <p:cNvPr id="3" name="Text 1"/>
-          <p:cNvSpPr/>
-          <p:nvPr/>
-        </p:nvSpPr>
-        <p:spPr>
-          <a:xfrm>
-            <a:off x="457200" y="1097280"/>
-            <a:ext cx="8229600" cy="1645920"/>
-          </a:xfrm>
-          <a:prstGeom prst="rect">
-            <a:avLst/>
-          </a:prstGeom>
-          <a:noFill/>
-          <a:ln/>
-        </p:spPr>
-        <p:txBody>
-          <a:bodyPr wrap="square" rtlCol="0" anchor="t"/>
-          <a:lstStyle/>
-          <a:p>
-            <a:pPr algn="ctr" indent="0" marL="0">
-              <a:buNone/>
-            </a:pPr>
-            <a:r>
-              <a:rPr lang="en-US" sz="3600" b="1" dirty="0">
-                <a:solidFill>
-                  <a:srgbClr val="FFFFFF"/>
-                </a:solidFill>
-              </a:rPr>
-              <a:t>Meet PACE™: Your IPO Progress Engine</a:t>
-            </a:r>
-            <a:endParaRPr lang="en-US" sz="3600" dirty="0"/>
-          </a:p>
-        </p:txBody>
-      </p:sp>
-      <p:sp>
-        <p:nvSpPr>
-          <p:cNvPr id="4" name="Text 2"/>
-          <p:cNvSpPr/>
-          <p:nvPr/>
-        </p:nvSpPr>
-        <p:spPr>
-          <a:xfrm>
-            <a:off x="457200" y="10789920"/>
-            <a:ext cx="8229600" cy="365760"/>
-          </a:xfrm>
-          <a:prstGeom prst="rect">
-            <a:avLst/>
-          </a:prstGeom>
-          <a:noFill/>
-          <a:ln/>
-        </p:spPr>
-        <p:txBody>
-          <a:bodyPr wrap="square" rtlCol="0" anchor="ctr"/>
-          <a:lstStyle/>
-          <a:p>
-            <a:pPr algn="ctr" indent="0" marL="0">
-              <a:buNone/>
-            </a:pPr>
-            <a:r>
-              <a:rPr lang="en-US" sz="1100" i="1" dirty="0">
-                <a:solidFill>
-                  <a:srgbClr val="FFFFFF"/>
-                </a:solidFill>
-              </a:rPr>
-              <a:t>LinkedIn Post 2</a:t>
-            </a:r>
-            <a:endParaRPr lang="en-US" sz="1100" dirty="0"/>
-          </a:p>
-        </p:txBody>
-      </p:sp>
-    </p:spTree>
-  </p:cSld>
-  <p:clrMapOvr>
-    <a:masterClrMapping/>
-  </p:clrMapOvr>
-</p:sld>
-</file>
-
-<file path=ppt/slides/slide3.xml><?xml version="1.0" encoding="utf-8"?>
-<p:sld xmlns:a="http://schemas.openxmlformats.org/drawingml/2006/main" xmlns:r="http://schemas.openxmlformats.org/officeDocument/2006/relationships" xmlns:p="http://schemas.openxmlformats.org/presentationml/2006/main">
-  <p:cSld name="Slide 3">
     <p:bg>
       <p:bgPr>
         <a:solidFill>
@@ -1608,69 +1628,53 @@
         </p:nvSpPr>
         <p:spPr>
           <a:xfrm>
-            <a:off x="4114800" y="274320"/>
-            <a:ext cx="914400" cy="548640"/>
-          </a:xfrm>
-          <a:prstGeom prst="rect">
-            <a:avLst/>
-          </a:prstGeom>
-          <a:noFill/>
-          <a:ln/>
-        </p:spPr>
-        <p:txBody>
-          <a:bodyPr wrap="square" rtlCol="0" anchor="ctr"/>
-          <a:lstStyle/>
-          <a:p>
-            <a:pPr algn="ctr" indent="0" marL="0">
-              <a:buNone/>
-            </a:pPr>
-            <a:r>
-              <a:rPr lang="en-US" sz="4800" dirty="0">
-                <a:solidFill>
-                  <a:srgbClr val="000000"/>
-                </a:solidFill>
-              </a:rPr>
-              <a:t>✅</a:t>
-            </a:r>
-            <a:endParaRPr lang="en-US" sz="4800" dirty="0"/>
-          </a:p>
-        </p:txBody>
-      </p:sp>
-      <p:sp>
-        <p:nvSpPr>
-          <p:cNvPr id="3" name="Text 1"/>
-          <p:cNvSpPr/>
-          <p:nvPr/>
-        </p:nvSpPr>
-        <p:spPr>
-          <a:xfrm>
-            <a:off x="457200" y="1097280"/>
-            <a:ext cx="8229600" cy="1645920"/>
-          </a:xfrm>
-          <a:prstGeom prst="rect">
-            <a:avLst/>
-          </a:prstGeom>
-          <a:noFill/>
-          <a:ln/>
-        </p:spPr>
-        <p:txBody>
-          <a:bodyPr wrap="square" rtlCol="0" anchor="t"/>
-          <a:lstStyle/>
-          <a:p>
-            <a:pPr algn="ctr" indent="0" marL="0">
-              <a:buNone/>
-            </a:pPr>
-            <a:r>
-              <a:rPr lang="en-US" sz="3600" b="1" dirty="0">
+            <a:off x="457200" y="365760"/>
+            <a:ext cx="8842248" cy="548640"/>
+          </a:xfrm>
+          <a:prstGeom prst="rect">
+            <a:avLst/>
+          </a:prstGeom>
+          <a:noFill/>
+          <a:ln/>
+        </p:spPr>
+        <p:txBody>
+          <a:bodyPr wrap="square" rtlCol="0" anchor="ctr"/>
+          <a:lstStyle/>
+          <a:p>
+            <a:pPr algn="ctr" indent="0" marL="0">
+              <a:buNone/>
+            </a:pPr>
+            <a:r>
+              <a:rPr lang="en-US" sz="4400" b="1" dirty="0">
                 <a:solidFill>
                   <a:srgbClr val="1E2761"/>
                 </a:solidFill>
               </a:rPr>
-              <a:t>From 8 Tools to One Coordinated System</a:t>
-            </a:r>
-            <a:endParaRPr lang="en-US" sz="3600" dirty="0"/>
-          </a:p>
-        </p:txBody>
+              <a:t>What is PACE™?</a:t>
+            </a:r>
+            <a:endParaRPr lang="en-US" sz="4400" dirty="0"/>
+          </a:p>
+        </p:txBody>
+      </p:sp>
+      <p:sp>
+        <p:nvSpPr>
+          <p:cNvPr id="3" name="Shape 1"/>
+          <p:cNvSpPr/>
+          <p:nvPr/>
+        </p:nvSpPr>
+        <p:spPr>
+          <a:xfrm>
+            <a:off x="731520" y="1371600"/>
+            <a:ext cx="3931920" cy="822960"/>
+          </a:xfrm>
+          <a:prstGeom prst="rect">
+            <a:avLst/>
+          </a:prstGeom>
+          <a:solidFill>
+            <a:srgbClr val="F96167"/>
+          </a:solidFill>
+          <a:ln/>
+        </p:spPr>
       </p:sp>
       <p:sp>
         <p:nvSpPr>
@@ -1680,31 +1684,783 @@
         </p:nvSpPr>
         <p:spPr>
           <a:xfrm>
-            <a:off x="457200" y="10789920"/>
-            <a:ext cx="8229600" cy="365760"/>
-          </a:xfrm>
-          <a:prstGeom prst="rect">
-            <a:avLst/>
-          </a:prstGeom>
-          <a:noFill/>
-          <a:ln/>
-        </p:spPr>
-        <p:txBody>
-          <a:bodyPr wrap="square" rtlCol="0" anchor="ctr"/>
-          <a:lstStyle/>
-          <a:p>
-            <a:pPr algn="ctr" indent="0" marL="0">
-              <a:buNone/>
-            </a:pPr>
-            <a:r>
-              <a:rPr lang="en-US" sz="1100" i="1" dirty="0">
+            <a:off x="731520" y="1371600"/>
+            <a:ext cx="3931920" cy="365760"/>
+          </a:xfrm>
+          <a:prstGeom prst="rect">
+            <a:avLst/>
+          </a:prstGeom>
+          <a:noFill/>
+          <a:ln/>
+        </p:spPr>
+        <p:txBody>
+          <a:bodyPr wrap="square" rtlCol="0" anchor="ctr"/>
+          <a:lstStyle/>
+          <a:p>
+            <a:pPr algn="ctr" indent="0" marL="0">
+              <a:buNone/>
+            </a:pPr>
+            <a:r>
+              <a:rPr lang="en-US" sz="1800" b="1" dirty="0">
+                <a:solidFill>
+                  <a:srgbClr val="FFFFFF"/>
+                </a:solidFill>
+              </a:rPr>
+              <a:t>Progress</a:t>
+            </a:r>
+            <a:endParaRPr lang="en-US" sz="1800" dirty="0"/>
+          </a:p>
+        </p:txBody>
+      </p:sp>
+      <p:sp>
+        <p:nvSpPr>
+          <p:cNvPr id="5" name="Text 3"/>
+          <p:cNvSpPr/>
+          <p:nvPr/>
+        </p:nvSpPr>
+        <p:spPr>
+          <a:xfrm>
+            <a:off x="731520" y="1783080"/>
+            <a:ext cx="3931920" cy="365760"/>
+          </a:xfrm>
+          <a:prstGeom prst="rect">
+            <a:avLst/>
+          </a:prstGeom>
+          <a:noFill/>
+          <a:ln/>
+        </p:spPr>
+        <p:txBody>
+          <a:bodyPr wrap="square" rtlCol="0" anchor="ctr"/>
+          <a:lstStyle/>
+          <a:p>
+            <a:pPr algn="ctr" indent="0" marL="0">
+              <a:buNone/>
+            </a:pPr>
+            <a:r>
+              <a:rPr lang="en-US" sz="1300" dirty="0">
+                <a:solidFill>
+                  <a:srgbClr val="FFFFFF"/>
+                </a:solidFill>
+              </a:rPr>
+              <a:t>Phase completion tracking</a:t>
+            </a:r>
+            <a:endParaRPr lang="en-US" sz="1300" dirty="0"/>
+          </a:p>
+        </p:txBody>
+      </p:sp>
+      <p:sp>
+        <p:nvSpPr>
+          <p:cNvPr id="6" name="Shape 4"/>
+          <p:cNvSpPr/>
+          <p:nvPr/>
+        </p:nvSpPr>
+        <p:spPr>
+          <a:xfrm>
+            <a:off x="5120640" y="1371600"/>
+            <a:ext cx="3931920" cy="822960"/>
+          </a:xfrm>
+          <a:prstGeom prst="rect">
+            <a:avLst/>
+          </a:prstGeom>
+          <a:solidFill>
+            <a:srgbClr val="1E2761"/>
+          </a:solidFill>
+          <a:ln/>
+        </p:spPr>
+      </p:sp>
+      <p:sp>
+        <p:nvSpPr>
+          <p:cNvPr id="7" name="Text 5"/>
+          <p:cNvSpPr/>
+          <p:nvPr/>
+        </p:nvSpPr>
+        <p:spPr>
+          <a:xfrm>
+            <a:off x="5120640" y="1371600"/>
+            <a:ext cx="3931920" cy="365760"/>
+          </a:xfrm>
+          <a:prstGeom prst="rect">
+            <a:avLst/>
+          </a:prstGeom>
+          <a:noFill/>
+          <a:ln/>
+        </p:spPr>
+        <p:txBody>
+          <a:bodyPr wrap="square" rtlCol="0" anchor="ctr"/>
+          <a:lstStyle/>
+          <a:p>
+            <a:pPr algn="ctr" indent="0" marL="0">
+              <a:buNone/>
+            </a:pPr>
+            <a:r>
+              <a:rPr lang="en-US" sz="1800" b="1" dirty="0">
+                <a:solidFill>
+                  <a:srgbClr val="FFFFFF"/>
+                </a:solidFill>
+              </a:rPr>
+              <a:t>Analysis</a:t>
+            </a:r>
+            <a:endParaRPr lang="en-US" sz="1800" dirty="0"/>
+          </a:p>
+        </p:txBody>
+      </p:sp>
+      <p:sp>
+        <p:nvSpPr>
+          <p:cNvPr id="8" name="Text 6"/>
+          <p:cNvSpPr/>
+          <p:nvPr/>
+        </p:nvSpPr>
+        <p:spPr>
+          <a:xfrm>
+            <a:off x="5120640" y="1783080"/>
+            <a:ext cx="3931920" cy="365760"/>
+          </a:xfrm>
+          <a:prstGeom prst="rect">
+            <a:avLst/>
+          </a:prstGeom>
+          <a:noFill/>
+          <a:ln/>
+        </p:spPr>
+        <p:txBody>
+          <a:bodyPr wrap="square" rtlCol="0" anchor="ctr"/>
+          <a:lstStyle/>
+          <a:p>
+            <a:pPr algn="ctr" indent="0" marL="0">
+              <a:buNone/>
+            </a:pPr>
+            <a:r>
+              <a:rPr lang="en-US" sz="1300" dirty="0">
+                <a:solidFill>
+                  <a:srgbClr val="FFFFFF"/>
+                </a:solidFill>
+              </a:rPr>
+              <a:t>Benchmarked against 500+ IPOs</a:t>
+            </a:r>
+            <a:endParaRPr lang="en-US" sz="1300" dirty="0"/>
+          </a:p>
+        </p:txBody>
+      </p:sp>
+      <p:sp>
+        <p:nvSpPr>
+          <p:cNvPr id="9" name="Shape 7"/>
+          <p:cNvSpPr/>
+          <p:nvPr/>
+        </p:nvSpPr>
+        <p:spPr>
+          <a:xfrm>
+            <a:off x="731520" y="2468880"/>
+            <a:ext cx="3931920" cy="822960"/>
+          </a:xfrm>
+          <a:prstGeom prst="rect">
+            <a:avLst/>
+          </a:prstGeom>
+          <a:solidFill>
+            <a:srgbClr val="F96167"/>
+          </a:solidFill>
+          <a:ln/>
+        </p:spPr>
+      </p:sp>
+      <p:sp>
+        <p:nvSpPr>
+          <p:cNvPr id="10" name="Text 8"/>
+          <p:cNvSpPr/>
+          <p:nvPr/>
+        </p:nvSpPr>
+        <p:spPr>
+          <a:xfrm>
+            <a:off x="731520" y="2468880"/>
+            <a:ext cx="3931920" cy="365760"/>
+          </a:xfrm>
+          <a:prstGeom prst="rect">
+            <a:avLst/>
+          </a:prstGeom>
+          <a:noFill/>
+          <a:ln/>
+        </p:spPr>
+        <p:txBody>
+          <a:bodyPr wrap="square" rtlCol="0" anchor="ctr"/>
+          <a:lstStyle/>
+          <a:p>
+            <a:pPr algn="ctr" indent="0" marL="0">
+              <a:buNone/>
+            </a:pPr>
+            <a:r>
+              <a:rPr lang="en-US" sz="1800" b="1" dirty="0">
+                <a:solidFill>
+                  <a:srgbClr val="FFFFFF"/>
+                </a:solidFill>
+              </a:rPr>
+              <a:t>Clarity</a:t>
+            </a:r>
+            <a:endParaRPr lang="en-US" sz="1800" dirty="0"/>
+          </a:p>
+        </p:txBody>
+      </p:sp>
+      <p:sp>
+        <p:nvSpPr>
+          <p:cNvPr id="11" name="Text 9"/>
+          <p:cNvSpPr/>
+          <p:nvPr/>
+        </p:nvSpPr>
+        <p:spPr>
+          <a:xfrm>
+            <a:off x="731520" y="2880360"/>
+            <a:ext cx="3931920" cy="365760"/>
+          </a:xfrm>
+          <a:prstGeom prst="rect">
+            <a:avLst/>
+          </a:prstGeom>
+          <a:noFill/>
+          <a:ln/>
+        </p:spPr>
+        <p:txBody>
+          <a:bodyPr wrap="square" rtlCol="0" anchor="ctr"/>
+          <a:lstStyle/>
+          <a:p>
+            <a:pPr algn="ctr" indent="0" marL="0">
+              <a:buNone/>
+            </a:pPr>
+            <a:r>
+              <a:rPr lang="en-US" sz="1300" dirty="0">
+                <a:solidFill>
+                  <a:srgbClr val="FFFFFF"/>
+                </a:solidFill>
+              </a:rPr>
+              <a:t>Real-time readiness insights</a:t>
+            </a:r>
+            <a:endParaRPr lang="en-US" sz="1300" dirty="0"/>
+          </a:p>
+        </p:txBody>
+      </p:sp>
+      <p:sp>
+        <p:nvSpPr>
+          <p:cNvPr id="12" name="Shape 10"/>
+          <p:cNvSpPr/>
+          <p:nvPr/>
+        </p:nvSpPr>
+        <p:spPr>
+          <a:xfrm>
+            <a:off x="5120640" y="2468880"/>
+            <a:ext cx="3931920" cy="822960"/>
+          </a:xfrm>
+          <a:prstGeom prst="rect">
+            <a:avLst/>
+          </a:prstGeom>
+          <a:solidFill>
+            <a:srgbClr val="1E2761"/>
+          </a:solidFill>
+          <a:ln/>
+        </p:spPr>
+      </p:sp>
+      <p:sp>
+        <p:nvSpPr>
+          <p:cNvPr id="13" name="Text 11"/>
+          <p:cNvSpPr/>
+          <p:nvPr/>
+        </p:nvSpPr>
+        <p:spPr>
+          <a:xfrm>
+            <a:off x="5120640" y="2468880"/>
+            <a:ext cx="3931920" cy="365760"/>
+          </a:xfrm>
+          <a:prstGeom prst="rect">
+            <a:avLst/>
+          </a:prstGeom>
+          <a:noFill/>
+          <a:ln/>
+        </p:spPr>
+        <p:txBody>
+          <a:bodyPr wrap="square" rtlCol="0" anchor="ctr"/>
+          <a:lstStyle/>
+          <a:p>
+            <a:pPr algn="ctr" indent="0" marL="0">
+              <a:buNone/>
+            </a:pPr>
+            <a:r>
+              <a:rPr lang="en-US" sz="1800" b="1" dirty="0">
+                <a:solidFill>
+                  <a:srgbClr val="FFFFFF"/>
+                </a:solidFill>
+              </a:rPr>
+              <a:t>Execution</a:t>
+            </a:r>
+            <a:endParaRPr lang="en-US" sz="1800" dirty="0"/>
+          </a:p>
+        </p:txBody>
+      </p:sp>
+      <p:sp>
+        <p:nvSpPr>
+          <p:cNvPr id="14" name="Text 12"/>
+          <p:cNvSpPr/>
+          <p:nvPr/>
+        </p:nvSpPr>
+        <p:spPr>
+          <a:xfrm>
+            <a:off x="5120640" y="2880360"/>
+            <a:ext cx="3931920" cy="365760"/>
+          </a:xfrm>
+          <a:prstGeom prst="rect">
+            <a:avLst/>
+          </a:prstGeom>
+          <a:noFill/>
+          <a:ln/>
+        </p:spPr>
+        <p:txBody>
+          <a:bodyPr wrap="square" rtlCol="0" anchor="ctr"/>
+          <a:lstStyle/>
+          <a:p>
+            <a:pPr algn="ctr" indent="0" marL="0">
+              <a:buNone/>
+            </a:pPr>
+            <a:r>
+              <a:rPr lang="en-US" sz="1300" dirty="0">
+                <a:solidFill>
+                  <a:srgbClr val="FFFFFF"/>
+                </a:solidFill>
+              </a:rPr>
+              <a:t>Actionable milestone sequencing</a:t>
+            </a:r>
+            <a:endParaRPr lang="en-US" sz="1300" dirty="0"/>
+          </a:p>
+        </p:txBody>
+      </p:sp>
+      <p:sp>
+        <p:nvSpPr>
+          <p:cNvPr id="15" name="Text 13"/>
+          <p:cNvSpPr/>
+          <p:nvPr/>
+        </p:nvSpPr>
+        <p:spPr>
+          <a:xfrm>
+            <a:off x="457200" y="365760"/>
+            <a:ext cx="8842248" cy="548640"/>
+          </a:xfrm>
+          <a:prstGeom prst="rect">
+            <a:avLst/>
+          </a:prstGeom>
+          <a:noFill/>
+          <a:ln/>
+        </p:spPr>
+        <p:txBody>
+          <a:bodyPr wrap="square" rtlCol="0" anchor="ctr"/>
+          <a:lstStyle/>
+          <a:p>
+            <a:pPr algn="ctr" indent="0" marL="0">
+              <a:buNone/>
+            </a:pPr>
+            <a:r>
+              <a:rPr lang="en-US" sz="4400" b="1" dirty="0">
                 <a:solidFill>
                   <a:srgbClr val="1E2761"/>
                 </a:solidFill>
               </a:rPr>
-              <a:t>LinkedIn Post 3</a:t>
-            </a:r>
-            <a:endParaRPr lang="en-US" sz="1100" dirty="0"/>
+              <a:t>What is PACE?</a:t>
+            </a:r>
+            <a:endParaRPr lang="en-US" sz="4400" dirty="0"/>
+          </a:p>
+        </p:txBody>
+      </p:sp>
+      <p:sp>
+        <p:nvSpPr>
+          <p:cNvPr id="16" name="Shape 14"/>
+          <p:cNvSpPr/>
+          <p:nvPr/>
+        </p:nvSpPr>
+        <p:spPr>
+          <a:xfrm>
+            <a:off x="731520" y="4846320"/>
+            <a:ext cx="3931920" cy="822960"/>
+          </a:xfrm>
+          <a:prstGeom prst="rect">
+            <a:avLst/>
+          </a:prstGeom>
+          <a:solidFill>
+            <a:srgbClr val="F96167"/>
+          </a:solidFill>
+          <a:ln/>
+        </p:spPr>
+      </p:sp>
+      <p:sp>
+        <p:nvSpPr>
+          <p:cNvPr id="17" name="Text 15"/>
+          <p:cNvSpPr/>
+          <p:nvPr/>
+        </p:nvSpPr>
+        <p:spPr>
+          <a:xfrm>
+            <a:off x="731520" y="4846320"/>
+            <a:ext cx="3931920" cy="365760"/>
+          </a:xfrm>
+          <a:prstGeom prst="rect">
+            <a:avLst/>
+          </a:prstGeom>
+          <a:noFill/>
+          <a:ln/>
+        </p:spPr>
+        <p:txBody>
+          <a:bodyPr wrap="square" rtlCol="0" anchor="ctr"/>
+          <a:lstStyle/>
+          <a:p>
+            <a:pPr algn="ctr" indent="0" marL="0">
+              <a:buNone/>
+            </a:pPr>
+            <a:r>
+              <a:rPr lang="en-US" sz="1800" b="1" dirty="0">
+                <a:solidFill>
+                  <a:srgbClr val="FFFFFF"/>
+                </a:solidFill>
+              </a:rPr>
+              <a:t>Progress</a:t>
+            </a:r>
+            <a:endParaRPr lang="en-US" sz="1800" dirty="0"/>
+          </a:p>
+        </p:txBody>
+      </p:sp>
+      <p:sp>
+        <p:nvSpPr>
+          <p:cNvPr id="18" name="Text 16"/>
+          <p:cNvSpPr/>
+          <p:nvPr/>
+        </p:nvSpPr>
+        <p:spPr>
+          <a:xfrm>
+            <a:off x="731520" y="5257800"/>
+            <a:ext cx="3931920" cy="365760"/>
+          </a:xfrm>
+          <a:prstGeom prst="rect">
+            <a:avLst/>
+          </a:prstGeom>
+          <a:noFill/>
+          <a:ln/>
+        </p:spPr>
+        <p:txBody>
+          <a:bodyPr wrap="square" rtlCol="0" anchor="ctr"/>
+          <a:lstStyle/>
+          <a:p>
+            <a:pPr algn="ctr" indent="0" marL="0">
+              <a:buNone/>
+            </a:pPr>
+            <a:r>
+              <a:rPr lang="en-US" sz="1300" dirty="0">
+                <a:solidFill>
+                  <a:srgbClr val="FFFFFF"/>
+                </a:solidFill>
+              </a:rPr>
+              <a:t>Phase completion tracking</a:t>
+            </a:r>
+            <a:endParaRPr lang="en-US" sz="1300" dirty="0"/>
+          </a:p>
+        </p:txBody>
+      </p:sp>
+      <p:sp>
+        <p:nvSpPr>
+          <p:cNvPr id="19" name="Shape 17"/>
+          <p:cNvSpPr/>
+          <p:nvPr/>
+        </p:nvSpPr>
+        <p:spPr>
+          <a:xfrm>
+            <a:off x="5120640" y="4846320"/>
+            <a:ext cx="3931920" cy="822960"/>
+          </a:xfrm>
+          <a:prstGeom prst="rect">
+            <a:avLst/>
+          </a:prstGeom>
+          <a:solidFill>
+            <a:srgbClr val="1E2761"/>
+          </a:solidFill>
+          <a:ln/>
+        </p:spPr>
+      </p:sp>
+      <p:sp>
+        <p:nvSpPr>
+          <p:cNvPr id="20" name="Text 18"/>
+          <p:cNvSpPr/>
+          <p:nvPr/>
+        </p:nvSpPr>
+        <p:spPr>
+          <a:xfrm>
+            <a:off x="5120640" y="4846320"/>
+            <a:ext cx="3931920" cy="365760"/>
+          </a:xfrm>
+          <a:prstGeom prst="rect">
+            <a:avLst/>
+          </a:prstGeom>
+          <a:noFill/>
+          <a:ln/>
+        </p:spPr>
+        <p:txBody>
+          <a:bodyPr wrap="square" rtlCol="0" anchor="ctr"/>
+          <a:lstStyle/>
+          <a:p>
+            <a:pPr algn="ctr" indent="0" marL="0">
+              <a:buNone/>
+            </a:pPr>
+            <a:r>
+              <a:rPr lang="en-US" sz="1800" b="1" dirty="0">
+                <a:solidFill>
+                  <a:srgbClr val="FFFFFF"/>
+                </a:solidFill>
+              </a:rPr>
+              <a:t>Analysis</a:t>
+            </a:r>
+            <a:endParaRPr lang="en-US" sz="1800" dirty="0"/>
+          </a:p>
+        </p:txBody>
+      </p:sp>
+      <p:sp>
+        <p:nvSpPr>
+          <p:cNvPr id="21" name="Text 19"/>
+          <p:cNvSpPr/>
+          <p:nvPr/>
+        </p:nvSpPr>
+        <p:spPr>
+          <a:xfrm>
+            <a:off x="5120640" y="5257800"/>
+            <a:ext cx="3931920" cy="365760"/>
+          </a:xfrm>
+          <a:prstGeom prst="rect">
+            <a:avLst/>
+          </a:prstGeom>
+          <a:noFill/>
+          <a:ln/>
+        </p:spPr>
+        <p:txBody>
+          <a:bodyPr wrap="square" rtlCol="0" anchor="ctr"/>
+          <a:lstStyle/>
+          <a:p>
+            <a:pPr algn="ctr" indent="0" marL="0">
+              <a:buNone/>
+            </a:pPr>
+            <a:r>
+              <a:rPr lang="en-US" sz="1300" dirty="0">
+                <a:solidFill>
+                  <a:srgbClr val="FFFFFF"/>
+                </a:solidFill>
+              </a:rPr>
+              <a:t>Benchmarked against 500+ IPOs</a:t>
+            </a:r>
+            <a:endParaRPr lang="en-US" sz="1300" dirty="0"/>
+          </a:p>
+        </p:txBody>
+      </p:sp>
+      <p:sp>
+        <p:nvSpPr>
+          <p:cNvPr id="22" name="Shape 20"/>
+          <p:cNvSpPr/>
+          <p:nvPr/>
+        </p:nvSpPr>
+        <p:spPr>
+          <a:xfrm>
+            <a:off x="731520" y="5943600"/>
+            <a:ext cx="3931920" cy="822960"/>
+          </a:xfrm>
+          <a:prstGeom prst="rect">
+            <a:avLst/>
+          </a:prstGeom>
+          <a:solidFill>
+            <a:srgbClr val="F96167"/>
+          </a:solidFill>
+          <a:ln/>
+        </p:spPr>
+      </p:sp>
+      <p:sp>
+        <p:nvSpPr>
+          <p:cNvPr id="23" name="Text 21"/>
+          <p:cNvSpPr/>
+          <p:nvPr/>
+        </p:nvSpPr>
+        <p:spPr>
+          <a:xfrm>
+            <a:off x="731520" y="5943600"/>
+            <a:ext cx="3931920" cy="365760"/>
+          </a:xfrm>
+          <a:prstGeom prst="rect">
+            <a:avLst/>
+          </a:prstGeom>
+          <a:noFill/>
+          <a:ln/>
+        </p:spPr>
+        <p:txBody>
+          <a:bodyPr wrap="square" rtlCol="0" anchor="ctr"/>
+          <a:lstStyle/>
+          <a:p>
+            <a:pPr algn="ctr" indent="0" marL="0">
+              <a:buNone/>
+            </a:pPr>
+            <a:r>
+              <a:rPr lang="en-US" sz="1800" b="1" dirty="0">
+                <a:solidFill>
+                  <a:srgbClr val="FFFFFF"/>
+                </a:solidFill>
+              </a:rPr>
+              <a:t>Clarity</a:t>
+            </a:r>
+            <a:endParaRPr lang="en-US" sz="1800" dirty="0"/>
+          </a:p>
+        </p:txBody>
+      </p:sp>
+      <p:sp>
+        <p:nvSpPr>
+          <p:cNvPr id="24" name="Text 22"/>
+          <p:cNvSpPr/>
+          <p:nvPr/>
+        </p:nvSpPr>
+        <p:spPr>
+          <a:xfrm>
+            <a:off x="731520" y="6355080"/>
+            <a:ext cx="3931920" cy="365760"/>
+          </a:xfrm>
+          <a:prstGeom prst="rect">
+            <a:avLst/>
+          </a:prstGeom>
+          <a:noFill/>
+          <a:ln/>
+        </p:spPr>
+        <p:txBody>
+          <a:bodyPr wrap="square" rtlCol="0" anchor="ctr"/>
+          <a:lstStyle/>
+          <a:p>
+            <a:pPr algn="ctr" indent="0" marL="0">
+              <a:buNone/>
+            </a:pPr>
+            <a:r>
+              <a:rPr lang="en-US" sz="1300" dirty="0">
+                <a:solidFill>
+                  <a:srgbClr val="FFFFFF"/>
+                </a:solidFill>
+              </a:rPr>
+              <a:t>Real-time readiness insights</a:t>
+            </a:r>
+            <a:endParaRPr lang="en-US" sz="1300" dirty="0"/>
+          </a:p>
+        </p:txBody>
+      </p:sp>
+      <p:sp>
+        <p:nvSpPr>
+          <p:cNvPr id="25" name="Shape 23"/>
+          <p:cNvSpPr/>
+          <p:nvPr/>
+        </p:nvSpPr>
+        <p:spPr>
+          <a:xfrm>
+            <a:off x="5120640" y="5943600"/>
+            <a:ext cx="3931920" cy="822960"/>
+          </a:xfrm>
+          <a:prstGeom prst="rect">
+            <a:avLst/>
+          </a:prstGeom>
+          <a:solidFill>
+            <a:srgbClr val="1E2761"/>
+          </a:solidFill>
+          <a:ln/>
+        </p:spPr>
+      </p:sp>
+      <p:sp>
+        <p:nvSpPr>
+          <p:cNvPr id="26" name="Text 24"/>
+          <p:cNvSpPr/>
+          <p:nvPr/>
+        </p:nvSpPr>
+        <p:spPr>
+          <a:xfrm>
+            <a:off x="5120640" y="5943600"/>
+            <a:ext cx="3931920" cy="365760"/>
+          </a:xfrm>
+          <a:prstGeom prst="rect">
+            <a:avLst/>
+          </a:prstGeom>
+          <a:noFill/>
+          <a:ln/>
+        </p:spPr>
+        <p:txBody>
+          <a:bodyPr wrap="square" rtlCol="0" anchor="ctr"/>
+          <a:lstStyle/>
+          <a:p>
+            <a:pPr algn="ctr" indent="0" marL="0">
+              <a:buNone/>
+            </a:pPr>
+            <a:r>
+              <a:rPr lang="en-US" sz="1800" b="1" dirty="0">
+                <a:solidFill>
+                  <a:srgbClr val="FFFFFF"/>
+                </a:solidFill>
+              </a:rPr>
+              <a:t>Execution</a:t>
+            </a:r>
+            <a:endParaRPr lang="en-US" sz="1800" dirty="0"/>
+          </a:p>
+        </p:txBody>
+      </p:sp>
+      <p:sp>
+        <p:nvSpPr>
+          <p:cNvPr id="27" name="Text 25"/>
+          <p:cNvSpPr/>
+          <p:nvPr/>
+        </p:nvSpPr>
+        <p:spPr>
+          <a:xfrm>
+            <a:off x="5120640" y="6355080"/>
+            <a:ext cx="3931920" cy="365760"/>
+          </a:xfrm>
+          <a:prstGeom prst="rect">
+            <a:avLst/>
+          </a:prstGeom>
+          <a:noFill/>
+          <a:ln/>
+        </p:spPr>
+        <p:txBody>
+          <a:bodyPr wrap="square" rtlCol="0" anchor="ctr"/>
+          <a:lstStyle/>
+          <a:p>
+            <a:pPr algn="ctr" indent="0" marL="0">
+              <a:buNone/>
+            </a:pPr>
+            <a:r>
+              <a:rPr lang="en-US" sz="1300" dirty="0">
+                <a:solidFill>
+                  <a:srgbClr val="FFFFFF"/>
+                </a:solidFill>
+              </a:rPr>
+              <a:t>Actionable milestone sequencing</a:t>
+            </a:r>
+            <a:endParaRPr lang="en-US" sz="1300" dirty="0"/>
+          </a:p>
+        </p:txBody>
+      </p:sp>
+      <p:sp>
+        <p:nvSpPr>
+          <p:cNvPr id="28" name="Text 26"/>
+          <p:cNvSpPr/>
+          <p:nvPr/>
+        </p:nvSpPr>
+        <p:spPr>
+          <a:xfrm>
+            <a:off x="457200" y="4754880"/>
+            <a:ext cx="8842248" cy="548640"/>
+          </a:xfrm>
+          <a:prstGeom prst="rect">
+            <a:avLst/>
+          </a:prstGeom>
+          <a:noFill/>
+          <a:ln/>
+        </p:spPr>
+        <p:txBody>
+          <a:bodyPr wrap="square" rtlCol="0" anchor="ctr"/>
+          <a:lstStyle/>
+          <a:p>
+            <a:pPr algn="ctr" indent="0" marL="0">
+              <a:buNone/>
+            </a:pPr>
+            <a:r>
+              <a:rPr lang="en-US" sz="1600" i="1" dirty="0">
+                <a:solidFill>
+                  <a:srgbClr val="36454F"/>
+                </a:solidFill>
+              </a:rPr>
+              <a:t>Every company IPO journey is unique. PACE personalizes yours.</a:t>
+            </a:r>
+            <a:endParaRPr lang="en-US" sz="1600" dirty="0"/>
           </a:p>
         </p:txBody>
       </p:sp>
@@ -1716,13 +2472,13 @@
 </p:sld>
 </file>
 
-<file path=ppt/slides/slide4.xml><?xml version="1.0" encoding="utf-8"?>
+<file path=ppt/slides/slide3.xml><?xml version="1.0" encoding="utf-8"?>
 <p:sld xmlns:a="http://schemas.openxmlformats.org/drawingml/2006/main" xmlns:r="http://schemas.openxmlformats.org/officeDocument/2006/relationships" xmlns:p="http://schemas.openxmlformats.org/presentationml/2006/main">
-  <p:cSld name="Slide 4">
+  <p:cSld name="Slide 3">
     <p:bg>
       <p:bgPr>
         <a:solidFill>
-          <a:srgbClr val="B85042"/>
+          <a:srgbClr val="F9E795"/>
         </a:solidFill>
       </p:bgPr>
     </p:bg>
@@ -1748,29 +2504,29 @@
         </p:nvSpPr>
         <p:spPr>
           <a:xfrm>
-            <a:off x="4114800" y="274320"/>
-            <a:ext cx="914400" cy="548640"/>
-          </a:xfrm>
-          <a:prstGeom prst="rect">
-            <a:avLst/>
-          </a:prstGeom>
-          <a:noFill/>
-          <a:ln/>
-        </p:spPr>
-        <p:txBody>
-          <a:bodyPr wrap="square" rtlCol="0" anchor="ctr"/>
-          <a:lstStyle/>
-          <a:p>
-            <a:pPr algn="ctr" indent="0" marL="0">
-              <a:buNone/>
-            </a:pPr>
-            <a:r>
-              <a:rPr lang="en-US" sz="4800" dirty="0">
-                <a:solidFill>
-                  <a:srgbClr val="000000"/>
-                </a:solidFill>
-              </a:rPr>
-              <a:t>⚠️</a:t>
+            <a:off x="457200" y="548640"/>
+            <a:ext cx="8842248" cy="731520"/>
+          </a:xfrm>
+          <a:prstGeom prst="rect">
+            <a:avLst/>
+          </a:prstGeom>
+          <a:noFill/>
+          <a:ln/>
+        </p:spPr>
+        <p:txBody>
+          <a:bodyPr wrap="square" rtlCol="0" anchor="ctr"/>
+          <a:lstStyle/>
+          <a:p>
+            <a:pPr algn="ctr" indent="0" marL="0">
+              <a:buNone/>
+            </a:pPr>
+            <a:r>
+              <a:rPr lang="en-US" sz="4800" b="1" dirty="0">
+                <a:solidFill>
+                  <a:srgbClr val="1E2761"/>
+                </a:solidFill>
+              </a:rPr>
+              <a:t>Stop guessing. Start benchmarking.</a:t>
             </a:r>
             <a:endParaRPr lang="en-US" sz="4800" dirty="0"/>
           </a:p>
@@ -1784,31 +2540,31 @@
         </p:nvSpPr>
         <p:spPr>
           <a:xfrm>
-            <a:off x="457200" y="1097280"/>
-            <a:ext cx="8229600" cy="1645920"/>
-          </a:xfrm>
-          <a:prstGeom prst="rect">
-            <a:avLst/>
-          </a:prstGeom>
-          <a:noFill/>
-          <a:ln/>
-        </p:spPr>
-        <p:txBody>
-          <a:bodyPr wrap="square" rtlCol="0" anchor="t"/>
-          <a:lstStyle/>
-          <a:p>
-            <a:pPr algn="ctr" indent="0" marL="0">
-              <a:buNone/>
-            </a:pPr>
-            <a:r>
-              <a:rPr lang="en-US" sz="3600" b="1" dirty="0">
-                <a:solidFill>
-                  <a:srgbClr val="FFFFFF"/>
-                </a:solidFill>
-              </a:rPr>
-              <a:t>Why Milestone Sequencing Matters</a:t>
-            </a:r>
-            <a:endParaRPr lang="en-US" sz="3600" dirty="0"/>
+            <a:off x="914400" y="1645920"/>
+            <a:ext cx="7927848" cy="914400"/>
+          </a:xfrm>
+          <a:prstGeom prst="rect">
+            <a:avLst/>
+          </a:prstGeom>
+          <a:noFill/>
+          <a:ln/>
+        </p:spPr>
+        <p:txBody>
+          <a:bodyPr wrap="square" rtlCol="0" anchor="ctr"/>
+          <a:lstStyle/>
+          <a:p>
+            <a:pPr algn="ctr" indent="0" marL="0">
+              <a:buNone/>
+            </a:pPr>
+            <a:r>
+              <a:rPr lang="en-US" sz="1800" dirty="0">
+                <a:solidFill>
+                  <a:srgbClr val="36454F"/>
+                </a:solidFill>
+              </a:rPr>
+              <a:t>IPOReady compares your PACE™ score against 500+ successful IPOs across TSX, NASDAQ, NYSE, CSE, and OTC.</a:t>
+            </a:r>
+            <a:endParaRPr lang="en-US" sz="1800" dirty="0"/>
           </a:p>
         </p:txBody>
       </p:sp>
@@ -1820,31 +2576,499 @@
         </p:nvSpPr>
         <p:spPr>
           <a:xfrm>
-            <a:off x="457200" y="10789920"/>
-            <a:ext cx="8229600" cy="365760"/>
-          </a:xfrm>
-          <a:prstGeom prst="rect">
-            <a:avLst/>
-          </a:prstGeom>
-          <a:noFill/>
-          <a:ln/>
-        </p:spPr>
-        <p:txBody>
-          <a:bodyPr wrap="square" rtlCol="0" anchor="ctr"/>
-          <a:lstStyle/>
-          <a:p>
-            <a:pPr algn="ctr" indent="0" marL="0">
-              <a:buNone/>
-            </a:pPr>
-            <a:r>
-              <a:rPr lang="en-US" sz="1100" i="1" dirty="0">
-                <a:solidFill>
-                  <a:srgbClr val="FFFFFF"/>
-                </a:solidFill>
-              </a:rPr>
-              <a:t>LinkedIn Post 4</a:t>
-            </a:r>
-            <a:endParaRPr lang="en-US" sz="1100" dirty="0"/>
+            <a:off x="1371600" y="2926080"/>
+            <a:ext cx="2286000" cy="640080"/>
+          </a:xfrm>
+          <a:prstGeom prst="rect">
+            <a:avLst/>
+          </a:prstGeom>
+          <a:noFill/>
+          <a:ln/>
+        </p:spPr>
+        <p:txBody>
+          <a:bodyPr wrap="square" rtlCol="0" anchor="ctr"/>
+          <a:lstStyle/>
+          <a:p>
+            <a:pPr algn="ctr" indent="0" marL="0">
+              <a:buNone/>
+            </a:pPr>
+            <a:r>
+              <a:rPr lang="en-US" sz="3200" b="1" dirty="0">
+                <a:solidFill>
+                  <a:srgbClr val="F96167"/>
+                </a:solidFill>
+              </a:rPr>
+              <a:t>500+</a:t>
+            </a:r>
+            <a:endParaRPr lang="en-US" sz="3200" dirty="0"/>
+          </a:p>
+        </p:txBody>
+      </p:sp>
+      <p:sp>
+        <p:nvSpPr>
+          <p:cNvPr id="5" name="Text 3"/>
+          <p:cNvSpPr/>
+          <p:nvPr/>
+        </p:nvSpPr>
+        <p:spPr>
+          <a:xfrm>
+            <a:off x="1371600" y="3657600"/>
+            <a:ext cx="2286000" cy="457200"/>
+          </a:xfrm>
+          <a:prstGeom prst="rect">
+            <a:avLst/>
+          </a:prstGeom>
+          <a:noFill/>
+          <a:ln/>
+        </p:spPr>
+        <p:txBody>
+          <a:bodyPr wrap="square" rtlCol="0" anchor="ctr"/>
+          <a:lstStyle/>
+          <a:p>
+            <a:pPr algn="ctr" indent="0" marL="0">
+              <a:buNone/>
+            </a:pPr>
+            <a:r>
+              <a:rPr lang="en-US" sz="1300" dirty="0">
+                <a:solidFill>
+                  <a:srgbClr val="36454F"/>
+                </a:solidFill>
+              </a:rPr>
+              <a:t>IPOs Analyzed</a:t>
+            </a:r>
+            <a:endParaRPr lang="en-US" sz="1300" dirty="0"/>
+          </a:p>
+        </p:txBody>
+      </p:sp>
+      <p:sp>
+        <p:nvSpPr>
+          <p:cNvPr id="6" name="Text 4"/>
+          <p:cNvSpPr/>
+          <p:nvPr/>
+        </p:nvSpPr>
+        <p:spPr>
+          <a:xfrm>
+            <a:off x="4023360" y="2926080"/>
+            <a:ext cx="2286000" cy="640080"/>
+          </a:xfrm>
+          <a:prstGeom prst="rect">
+            <a:avLst/>
+          </a:prstGeom>
+          <a:noFill/>
+          <a:ln/>
+        </p:spPr>
+        <p:txBody>
+          <a:bodyPr wrap="square" rtlCol="0" anchor="ctr"/>
+          <a:lstStyle/>
+          <a:p>
+            <a:pPr algn="ctr" indent="0" marL="0">
+              <a:buNone/>
+            </a:pPr>
+            <a:r>
+              <a:rPr lang="en-US" sz="3200" b="1" dirty="0">
+                <a:solidFill>
+                  <a:srgbClr val="F96167"/>
+                </a:solidFill>
+              </a:rPr>
+              <a:t>8</a:t>
+            </a:r>
+            <a:endParaRPr lang="en-US" sz="3200" dirty="0"/>
+          </a:p>
+        </p:txBody>
+      </p:sp>
+      <p:sp>
+        <p:nvSpPr>
+          <p:cNvPr id="7" name="Text 5"/>
+          <p:cNvSpPr/>
+          <p:nvPr/>
+        </p:nvSpPr>
+        <p:spPr>
+          <a:xfrm>
+            <a:off x="4023360" y="3657600"/>
+            <a:ext cx="2286000" cy="457200"/>
+          </a:xfrm>
+          <a:prstGeom prst="rect">
+            <a:avLst/>
+          </a:prstGeom>
+          <a:noFill/>
+          <a:ln/>
+        </p:spPr>
+        <p:txBody>
+          <a:bodyPr wrap="square" rtlCol="0" anchor="ctr"/>
+          <a:lstStyle/>
+          <a:p>
+            <a:pPr algn="ctr" indent="0" marL="0">
+              <a:buNone/>
+            </a:pPr>
+            <a:r>
+              <a:rPr lang="en-US" sz="1300" dirty="0">
+                <a:solidFill>
+                  <a:srgbClr val="36454F"/>
+                </a:solidFill>
+              </a:rPr>
+              <a:t>Phase Benchmarks</a:t>
+            </a:r>
+            <a:endParaRPr lang="en-US" sz="1300" dirty="0"/>
+          </a:p>
+        </p:txBody>
+      </p:sp>
+      <p:sp>
+        <p:nvSpPr>
+          <p:cNvPr id="8" name="Text 6"/>
+          <p:cNvSpPr/>
+          <p:nvPr/>
+        </p:nvSpPr>
+        <p:spPr>
+          <a:xfrm>
+            <a:off x="6675120" y="2926080"/>
+            <a:ext cx="2286000" cy="640080"/>
+          </a:xfrm>
+          <a:prstGeom prst="rect">
+            <a:avLst/>
+          </a:prstGeom>
+          <a:noFill/>
+          <a:ln/>
+        </p:spPr>
+        <p:txBody>
+          <a:bodyPr wrap="square" rtlCol="0" anchor="ctr"/>
+          <a:lstStyle/>
+          <a:p>
+            <a:pPr algn="ctr" indent="0" marL="0">
+              <a:buNone/>
+            </a:pPr>
+            <a:r>
+              <a:rPr lang="en-US" sz="3200" b="1" dirty="0">
+                <a:solidFill>
+                  <a:srgbClr val="F96167"/>
+                </a:solidFill>
+              </a:rPr>
+              <a:t>7</a:t>
+            </a:r>
+            <a:endParaRPr lang="en-US" sz="3200" dirty="0"/>
+          </a:p>
+        </p:txBody>
+      </p:sp>
+      <p:sp>
+        <p:nvSpPr>
+          <p:cNvPr id="9" name="Text 7"/>
+          <p:cNvSpPr/>
+          <p:nvPr/>
+        </p:nvSpPr>
+        <p:spPr>
+          <a:xfrm>
+            <a:off x="6675120" y="3657600"/>
+            <a:ext cx="2286000" cy="457200"/>
+          </a:xfrm>
+          <a:prstGeom prst="rect">
+            <a:avLst/>
+          </a:prstGeom>
+          <a:noFill/>
+          <a:ln/>
+        </p:spPr>
+        <p:txBody>
+          <a:bodyPr wrap="square" rtlCol="0" anchor="ctr"/>
+          <a:lstStyle/>
+          <a:p>
+            <a:pPr algn="ctr" indent="0" marL="0">
+              <a:buNone/>
+            </a:pPr>
+            <a:r>
+              <a:rPr lang="en-US" sz="1300" dirty="0">
+                <a:solidFill>
+                  <a:srgbClr val="36454F"/>
+                </a:solidFill>
+              </a:rPr>
+              <a:t>Exchanges Covered</a:t>
+            </a:r>
+            <a:endParaRPr lang="en-US" sz="1300" dirty="0"/>
+          </a:p>
+        </p:txBody>
+      </p:sp>
+      <p:sp>
+        <p:nvSpPr>
+          <p:cNvPr id="10" name="Text 8"/>
+          <p:cNvSpPr/>
+          <p:nvPr/>
+        </p:nvSpPr>
+        <p:spPr>
+          <a:xfrm>
+            <a:off x="457200" y="548640"/>
+            <a:ext cx="8842248" cy="731520"/>
+          </a:xfrm>
+          <a:prstGeom prst="rect">
+            <a:avLst/>
+          </a:prstGeom>
+          <a:noFill/>
+          <a:ln/>
+        </p:spPr>
+        <p:txBody>
+          <a:bodyPr wrap="square" rtlCol="0" anchor="ctr"/>
+          <a:lstStyle/>
+          <a:p>
+            <a:pPr algn="ctr" indent="0" marL="0">
+              <a:buNone/>
+            </a:pPr>
+            <a:r>
+              <a:rPr lang="en-US" sz="4800" b="1" dirty="0">
+                <a:solidFill>
+                  <a:srgbClr val="1E2761"/>
+                </a:solidFill>
+              </a:rPr>
+              <a:t>Stop guessing. Start benchmarking.</a:t>
+            </a:r>
+            <a:endParaRPr lang="en-US" sz="4800" dirty="0"/>
+          </a:p>
+        </p:txBody>
+      </p:sp>
+      <p:sp>
+        <p:nvSpPr>
+          <p:cNvPr id="11" name="Text 9"/>
+          <p:cNvSpPr/>
+          <p:nvPr/>
+        </p:nvSpPr>
+        <p:spPr>
+          <a:xfrm>
+            <a:off x="914400" y="1645920"/>
+            <a:ext cx="7927848" cy="914400"/>
+          </a:xfrm>
+          <a:prstGeom prst="rect">
+            <a:avLst/>
+          </a:prstGeom>
+          <a:noFill/>
+          <a:ln/>
+        </p:spPr>
+        <p:txBody>
+          <a:bodyPr wrap="square" rtlCol="0" anchor="ctr"/>
+          <a:lstStyle/>
+          <a:p>
+            <a:pPr algn="ctr" indent="0" marL="0">
+              <a:buNone/>
+            </a:pPr>
+            <a:r>
+              <a:rPr lang="en-US" sz="1800" dirty="0">
+                <a:solidFill>
+                  <a:srgbClr val="36454F"/>
+                </a:solidFill>
+              </a:rPr>
+              <a:t>IPOReady compares your PACE score against 500+ successful IPOs across TSX, NASDAQ, NYSE, CSE, and OTC.</a:t>
+            </a:r>
+            <a:endParaRPr lang="en-US" sz="1800" dirty="0"/>
+          </a:p>
+        </p:txBody>
+      </p:sp>
+      <p:sp>
+        <p:nvSpPr>
+          <p:cNvPr id="12" name="Text 10"/>
+          <p:cNvSpPr/>
+          <p:nvPr/>
+        </p:nvSpPr>
+        <p:spPr>
+          <a:xfrm>
+            <a:off x="1371600" y="2926080"/>
+            <a:ext cx="2286000" cy="640080"/>
+          </a:xfrm>
+          <a:prstGeom prst="rect">
+            <a:avLst/>
+          </a:prstGeom>
+          <a:noFill/>
+          <a:ln/>
+        </p:spPr>
+        <p:txBody>
+          <a:bodyPr wrap="square" rtlCol="0" anchor="ctr"/>
+          <a:lstStyle/>
+          <a:p>
+            <a:pPr algn="ctr" indent="0" marL="0">
+              <a:buNone/>
+            </a:pPr>
+            <a:r>
+              <a:rPr lang="en-US" sz="3200" b="1" dirty="0">
+                <a:solidFill>
+                  <a:srgbClr val="F96167"/>
+                </a:solidFill>
+              </a:rPr>
+              <a:t>500+</a:t>
+            </a:r>
+            <a:endParaRPr lang="en-US" sz="3200" dirty="0"/>
+          </a:p>
+        </p:txBody>
+      </p:sp>
+      <p:sp>
+        <p:nvSpPr>
+          <p:cNvPr id="13" name="Text 11"/>
+          <p:cNvSpPr/>
+          <p:nvPr/>
+        </p:nvSpPr>
+        <p:spPr>
+          <a:xfrm>
+            <a:off x="1371600" y="3657600"/>
+            <a:ext cx="2286000" cy="457200"/>
+          </a:xfrm>
+          <a:prstGeom prst="rect">
+            <a:avLst/>
+          </a:prstGeom>
+          <a:noFill/>
+          <a:ln/>
+        </p:spPr>
+        <p:txBody>
+          <a:bodyPr wrap="square" rtlCol="0" anchor="ctr"/>
+          <a:lstStyle/>
+          <a:p>
+            <a:pPr algn="ctr" indent="0" marL="0">
+              <a:buNone/>
+            </a:pPr>
+            <a:r>
+              <a:rPr lang="en-US" sz="1300" dirty="0">
+                <a:solidFill>
+                  <a:srgbClr val="36454F"/>
+                </a:solidFill>
+              </a:rPr>
+              <a:t>IPOs Analyzed</a:t>
+            </a:r>
+            <a:endParaRPr lang="en-US" sz="1300" dirty="0"/>
+          </a:p>
+        </p:txBody>
+      </p:sp>
+      <p:sp>
+        <p:nvSpPr>
+          <p:cNvPr id="14" name="Text 12"/>
+          <p:cNvSpPr/>
+          <p:nvPr/>
+        </p:nvSpPr>
+        <p:spPr>
+          <a:xfrm>
+            <a:off x="4023360" y="2926080"/>
+            <a:ext cx="2286000" cy="640080"/>
+          </a:xfrm>
+          <a:prstGeom prst="rect">
+            <a:avLst/>
+          </a:prstGeom>
+          <a:noFill/>
+          <a:ln/>
+        </p:spPr>
+        <p:txBody>
+          <a:bodyPr wrap="square" rtlCol="0" anchor="ctr"/>
+          <a:lstStyle/>
+          <a:p>
+            <a:pPr algn="ctr" indent="0" marL="0">
+              <a:buNone/>
+            </a:pPr>
+            <a:r>
+              <a:rPr lang="en-US" sz="3200" b="1" dirty="0">
+                <a:solidFill>
+                  <a:srgbClr val="F96167"/>
+                </a:solidFill>
+              </a:rPr>
+              <a:t>8</a:t>
+            </a:r>
+            <a:endParaRPr lang="en-US" sz="3200" dirty="0"/>
+          </a:p>
+        </p:txBody>
+      </p:sp>
+      <p:sp>
+        <p:nvSpPr>
+          <p:cNvPr id="15" name="Text 13"/>
+          <p:cNvSpPr/>
+          <p:nvPr/>
+        </p:nvSpPr>
+        <p:spPr>
+          <a:xfrm>
+            <a:off x="4023360" y="3657600"/>
+            <a:ext cx="2286000" cy="457200"/>
+          </a:xfrm>
+          <a:prstGeom prst="rect">
+            <a:avLst/>
+          </a:prstGeom>
+          <a:noFill/>
+          <a:ln/>
+        </p:spPr>
+        <p:txBody>
+          <a:bodyPr wrap="square" rtlCol="0" anchor="ctr"/>
+          <a:lstStyle/>
+          <a:p>
+            <a:pPr algn="ctr" indent="0" marL="0">
+              <a:buNone/>
+            </a:pPr>
+            <a:r>
+              <a:rPr lang="en-US" sz="1300" dirty="0">
+                <a:solidFill>
+                  <a:srgbClr val="36454F"/>
+                </a:solidFill>
+              </a:rPr>
+              <a:t>Phase Benchmarks</a:t>
+            </a:r>
+            <a:endParaRPr lang="en-US" sz="1300" dirty="0"/>
+          </a:p>
+        </p:txBody>
+      </p:sp>
+      <p:sp>
+        <p:nvSpPr>
+          <p:cNvPr id="16" name="Text 14"/>
+          <p:cNvSpPr/>
+          <p:nvPr/>
+        </p:nvSpPr>
+        <p:spPr>
+          <a:xfrm>
+            <a:off x="6675120" y="2926080"/>
+            <a:ext cx="2286000" cy="640080"/>
+          </a:xfrm>
+          <a:prstGeom prst="rect">
+            <a:avLst/>
+          </a:prstGeom>
+          <a:noFill/>
+          <a:ln/>
+        </p:spPr>
+        <p:txBody>
+          <a:bodyPr wrap="square" rtlCol="0" anchor="ctr"/>
+          <a:lstStyle/>
+          <a:p>
+            <a:pPr algn="ctr" indent="0" marL="0">
+              <a:buNone/>
+            </a:pPr>
+            <a:r>
+              <a:rPr lang="en-US" sz="3200" b="1" dirty="0">
+                <a:solidFill>
+                  <a:srgbClr val="F96167"/>
+                </a:solidFill>
+              </a:rPr>
+              <a:t>7</a:t>
+            </a:r>
+            <a:endParaRPr lang="en-US" sz="3200" dirty="0"/>
+          </a:p>
+        </p:txBody>
+      </p:sp>
+      <p:sp>
+        <p:nvSpPr>
+          <p:cNvPr id="17" name="Text 15"/>
+          <p:cNvSpPr/>
+          <p:nvPr/>
+        </p:nvSpPr>
+        <p:spPr>
+          <a:xfrm>
+            <a:off x="6675120" y="3657600"/>
+            <a:ext cx="2286000" cy="457200"/>
+          </a:xfrm>
+          <a:prstGeom prst="rect">
+            <a:avLst/>
+          </a:prstGeom>
+          <a:noFill/>
+          <a:ln/>
+        </p:spPr>
+        <p:txBody>
+          <a:bodyPr wrap="square" rtlCol="0" anchor="ctr"/>
+          <a:lstStyle/>
+          <a:p>
+            <a:pPr algn="ctr" indent="0" marL="0">
+              <a:buNone/>
+            </a:pPr>
+            <a:r>
+              <a:rPr lang="en-US" sz="1300" dirty="0">
+                <a:solidFill>
+                  <a:srgbClr val="36454F"/>
+                </a:solidFill>
+              </a:rPr>
+              <a:t>Exchanges Covered</a:t>
+            </a:r>
+            <a:endParaRPr lang="en-US" sz="1300" dirty="0"/>
           </a:p>
         </p:txBody>
       </p:sp>
@@ -1856,13 +3080,13 @@
 </p:sld>
 </file>
 
-<file path=ppt/slides/slide5.xml><?xml version="1.0" encoding="utf-8"?>
+<file path=ppt/slides/slide4.xml><?xml version="1.0" encoding="utf-8"?>
 <p:sld xmlns:a="http://schemas.openxmlformats.org/drawingml/2006/main" xmlns:r="http://schemas.openxmlformats.org/officeDocument/2006/relationships" xmlns:p="http://schemas.openxmlformats.org/presentationml/2006/main">
-  <p:cSld name="Slide 5">
+  <p:cSld name="Slide 4">
     <p:bg>
       <p:bgPr>
         <a:solidFill>
-          <a:srgbClr val="065A82"/>
+          <a:srgbClr val="FFFFFF"/>
         </a:solidFill>
       </p:bgPr>
     </p:bg>
@@ -1888,69 +3112,53 @@
         </p:nvSpPr>
         <p:spPr>
           <a:xfrm>
-            <a:off x="4114800" y="274320"/>
-            <a:ext cx="914400" cy="548640"/>
-          </a:xfrm>
-          <a:prstGeom prst="rect">
-            <a:avLst/>
-          </a:prstGeom>
-          <a:noFill/>
-          <a:ln/>
-        </p:spPr>
-        <p:txBody>
-          <a:bodyPr wrap="square" rtlCol="0" anchor="ctr"/>
-          <a:lstStyle/>
-          <a:p>
-            <a:pPr algn="ctr" indent="0" marL="0">
-              <a:buNone/>
-            </a:pPr>
-            <a:r>
-              <a:rPr lang="en-US" sz="4800" dirty="0">
-                <a:solidFill>
-                  <a:srgbClr val="000000"/>
-                </a:solidFill>
-              </a:rPr>
-              <a:t>📊</a:t>
-            </a:r>
-            <a:endParaRPr lang="en-US" sz="4800" dirty="0"/>
-          </a:p>
-        </p:txBody>
-      </p:sp>
-      <p:sp>
-        <p:nvSpPr>
-          <p:cNvPr id="3" name="Text 1"/>
-          <p:cNvSpPr/>
-          <p:nvPr/>
-        </p:nvSpPr>
-        <p:spPr>
-          <a:xfrm>
-            <a:off x="457200" y="1097280"/>
-            <a:ext cx="8229600" cy="1645920"/>
-          </a:xfrm>
-          <a:prstGeom prst="rect">
-            <a:avLst/>
-          </a:prstGeom>
-          <a:noFill/>
-          <a:ln/>
-        </p:spPr>
-        <p:txBody>
-          <a:bodyPr wrap="square" rtlCol="0" anchor="t"/>
-          <a:lstStyle/>
-          <a:p>
-            <a:pPr algn="ctr" indent="0" marL="0">
-              <a:buNone/>
-            </a:pPr>
-            <a:r>
-              <a:rPr lang="en-US" sz="3600" b="1" dirty="0">
-                <a:solidFill>
-                  <a:srgbClr val="FFFFFF"/>
-                </a:solidFill>
-              </a:rPr>
-              <a:t>Your Peer Percentile: How You Stack Up</a:t>
-            </a:r>
-            <a:endParaRPr lang="en-US" sz="3600" dirty="0"/>
-          </a:p>
-        </p:txBody>
+            <a:off x="457200" y="457200"/>
+            <a:ext cx="8842248" cy="640080"/>
+          </a:xfrm>
+          <a:prstGeom prst="rect">
+            <a:avLst/>
+          </a:prstGeom>
+          <a:noFill/>
+          <a:ln/>
+        </p:spPr>
+        <p:txBody>
+          <a:bodyPr wrap="square" rtlCol="0" anchor="ctr"/>
+          <a:lstStyle/>
+          <a:p>
+            <a:pPr algn="ctr" indent="0" marL="0">
+              <a:buNone/>
+            </a:pPr>
+            <a:r>
+              <a:rPr lang="en-US" sz="4200" b="1" dirty="0">
+                <a:solidFill>
+                  <a:srgbClr val="1E2761"/>
+                </a:solidFill>
+              </a:rPr>
+              <a:t>From Day 1 to IPO Day</a:t>
+            </a:r>
+            <a:endParaRPr lang="en-US" sz="4200" dirty="0"/>
+          </a:p>
+        </p:txBody>
+      </p:sp>
+      <p:sp>
+        <p:nvSpPr>
+          <p:cNvPr id="3" name="Shape 1"/>
+          <p:cNvSpPr/>
+          <p:nvPr/>
+        </p:nvSpPr>
+        <p:spPr>
+          <a:xfrm>
+            <a:off x="731520" y="1463040"/>
+            <a:ext cx="3931920" cy="457200"/>
+          </a:xfrm>
+          <a:prstGeom prst="rect">
+            <a:avLst/>
+          </a:prstGeom>
+          <a:solidFill>
+            <a:srgbClr val="F96167"/>
+          </a:solidFill>
+          <a:ln/>
+        </p:spPr>
       </p:sp>
       <p:sp>
         <p:nvSpPr>
@@ -1960,31 +3168,907 @@
         </p:nvSpPr>
         <p:spPr>
           <a:xfrm>
-            <a:off x="457200" y="10789920"/>
-            <a:ext cx="8229600" cy="365760"/>
-          </a:xfrm>
-          <a:prstGeom prst="rect">
-            <a:avLst/>
-          </a:prstGeom>
-          <a:noFill/>
-          <a:ln/>
-        </p:spPr>
-        <p:txBody>
-          <a:bodyPr wrap="square" rtlCol="0" anchor="ctr"/>
-          <a:lstStyle/>
-          <a:p>
-            <a:pPr algn="ctr" indent="0" marL="0">
-              <a:buNone/>
-            </a:pPr>
-            <a:r>
-              <a:rPr lang="en-US" sz="1100" i="1" dirty="0">
-                <a:solidFill>
-                  <a:srgbClr val="FFFFFF"/>
-                </a:solidFill>
-              </a:rPr>
-              <a:t>LinkedIn Post 5</a:t>
-            </a:r>
-            <a:endParaRPr lang="en-US" sz="1100" dirty="0"/>
+            <a:off x="731520" y="1463040"/>
+            <a:ext cx="3931920" cy="457200"/>
+          </a:xfrm>
+          <a:prstGeom prst="rect">
+            <a:avLst/>
+          </a:prstGeom>
+          <a:noFill/>
+          <a:ln/>
+        </p:spPr>
+        <p:txBody>
+          <a:bodyPr wrap="square" rtlCol="0" anchor="ctr"/>
+          <a:lstStyle/>
+          <a:p>
+            <a:pPr algn="ctr" indent="0" marL="0">
+              <a:buNone/>
+            </a:pPr>
+            <a:r>
+              <a:rPr lang="en-US" sz="1300" b="1" dirty="0">
+                <a:solidFill>
+                  <a:srgbClr val="FFFFFF"/>
+                </a:solidFill>
+              </a:rPr>
+              <a:t>1. Governance</a:t>
+            </a:r>
+            <a:endParaRPr lang="en-US" sz="1300" dirty="0"/>
+          </a:p>
+        </p:txBody>
+      </p:sp>
+      <p:sp>
+        <p:nvSpPr>
+          <p:cNvPr id="5" name="Shape 3"/>
+          <p:cNvSpPr/>
+          <p:nvPr/>
+        </p:nvSpPr>
+        <p:spPr>
+          <a:xfrm>
+            <a:off x="731520" y="2057400"/>
+            <a:ext cx="3931920" cy="457200"/>
+          </a:xfrm>
+          <a:prstGeom prst="rect">
+            <a:avLst/>
+          </a:prstGeom>
+          <a:solidFill>
+            <a:srgbClr val="1E2761"/>
+          </a:solidFill>
+          <a:ln/>
+        </p:spPr>
+      </p:sp>
+      <p:sp>
+        <p:nvSpPr>
+          <p:cNvPr id="6" name="Text 4"/>
+          <p:cNvSpPr/>
+          <p:nvPr/>
+        </p:nvSpPr>
+        <p:spPr>
+          <a:xfrm>
+            <a:off x="731520" y="2057400"/>
+            <a:ext cx="3931920" cy="457200"/>
+          </a:xfrm>
+          <a:prstGeom prst="rect">
+            <a:avLst/>
+          </a:prstGeom>
+          <a:noFill/>
+          <a:ln/>
+        </p:spPr>
+        <p:txBody>
+          <a:bodyPr wrap="square" rtlCol="0" anchor="ctr"/>
+          <a:lstStyle/>
+          <a:p>
+            <a:pPr algn="ctr" indent="0" marL="0">
+              <a:buNone/>
+            </a:pPr>
+            <a:r>
+              <a:rPr lang="en-US" sz="1300" b="1" dirty="0">
+                <a:solidFill>
+                  <a:srgbClr val="FFFFFF"/>
+                </a:solidFill>
+              </a:rPr>
+              <a:t>2. Financial Audit</a:t>
+            </a:r>
+            <a:endParaRPr lang="en-US" sz="1300" dirty="0"/>
+          </a:p>
+        </p:txBody>
+      </p:sp>
+      <p:sp>
+        <p:nvSpPr>
+          <p:cNvPr id="7" name="Shape 5"/>
+          <p:cNvSpPr/>
+          <p:nvPr/>
+        </p:nvSpPr>
+        <p:spPr>
+          <a:xfrm>
+            <a:off x="731520" y="2651760"/>
+            <a:ext cx="3931920" cy="457200"/>
+          </a:xfrm>
+          <a:prstGeom prst="rect">
+            <a:avLst/>
+          </a:prstGeom>
+          <a:solidFill>
+            <a:srgbClr val="F96167"/>
+          </a:solidFill>
+          <a:ln/>
+        </p:spPr>
+      </p:sp>
+      <p:sp>
+        <p:nvSpPr>
+          <p:cNvPr id="8" name="Text 6"/>
+          <p:cNvSpPr/>
+          <p:nvPr/>
+        </p:nvSpPr>
+        <p:spPr>
+          <a:xfrm>
+            <a:off x="731520" y="2651760"/>
+            <a:ext cx="3931920" cy="457200"/>
+          </a:xfrm>
+          <a:prstGeom prst="rect">
+            <a:avLst/>
+          </a:prstGeom>
+          <a:noFill/>
+          <a:ln/>
+        </p:spPr>
+        <p:txBody>
+          <a:bodyPr wrap="square" rtlCol="0" anchor="ctr"/>
+          <a:lstStyle/>
+          <a:p>
+            <a:pPr algn="ctr" indent="0" marL="0">
+              <a:buNone/>
+            </a:pPr>
+            <a:r>
+              <a:rPr lang="en-US" sz="1300" b="1" dirty="0">
+                <a:solidFill>
+                  <a:srgbClr val="FFFFFF"/>
+                </a:solidFill>
+              </a:rPr>
+              <a:t>3. Legal Documentation</a:t>
+            </a:r>
+            <a:endParaRPr lang="en-US" sz="1300" dirty="0"/>
+          </a:p>
+        </p:txBody>
+      </p:sp>
+      <p:sp>
+        <p:nvSpPr>
+          <p:cNvPr id="9" name="Shape 7"/>
+          <p:cNvSpPr/>
+          <p:nvPr/>
+        </p:nvSpPr>
+        <p:spPr>
+          <a:xfrm>
+            <a:off x="731520" y="3246120"/>
+            <a:ext cx="3931920" cy="457200"/>
+          </a:xfrm>
+          <a:prstGeom prst="rect">
+            <a:avLst/>
+          </a:prstGeom>
+          <a:solidFill>
+            <a:srgbClr val="1E2761"/>
+          </a:solidFill>
+          <a:ln/>
+        </p:spPr>
+      </p:sp>
+      <p:sp>
+        <p:nvSpPr>
+          <p:cNvPr id="10" name="Text 8"/>
+          <p:cNvSpPr/>
+          <p:nvPr/>
+        </p:nvSpPr>
+        <p:spPr>
+          <a:xfrm>
+            <a:off x="731520" y="3246120"/>
+            <a:ext cx="3931920" cy="457200"/>
+          </a:xfrm>
+          <a:prstGeom prst="rect">
+            <a:avLst/>
+          </a:prstGeom>
+          <a:noFill/>
+          <a:ln/>
+        </p:spPr>
+        <p:txBody>
+          <a:bodyPr wrap="square" rtlCol="0" anchor="ctr"/>
+          <a:lstStyle/>
+          <a:p>
+            <a:pPr algn="ctr" indent="0" marL="0">
+              <a:buNone/>
+            </a:pPr>
+            <a:r>
+              <a:rPr lang="en-US" sz="1300" b="1" dirty="0">
+                <a:solidFill>
+                  <a:srgbClr val="FFFFFF"/>
+                </a:solidFill>
+              </a:rPr>
+              <a:t>4. Compliance Review</a:t>
+            </a:r>
+            <a:endParaRPr lang="en-US" sz="1300" dirty="0"/>
+          </a:p>
+        </p:txBody>
+      </p:sp>
+      <p:sp>
+        <p:nvSpPr>
+          <p:cNvPr id="11" name="Shape 9"/>
+          <p:cNvSpPr/>
+          <p:nvPr/>
+        </p:nvSpPr>
+        <p:spPr>
+          <a:xfrm>
+            <a:off x="5120640" y="1463040"/>
+            <a:ext cx="3931920" cy="457200"/>
+          </a:xfrm>
+          <a:prstGeom prst="rect">
+            <a:avLst/>
+          </a:prstGeom>
+          <a:solidFill>
+            <a:srgbClr val="F96167"/>
+          </a:solidFill>
+          <a:ln/>
+        </p:spPr>
+      </p:sp>
+      <p:sp>
+        <p:nvSpPr>
+          <p:cNvPr id="12" name="Text 10"/>
+          <p:cNvSpPr/>
+          <p:nvPr/>
+        </p:nvSpPr>
+        <p:spPr>
+          <a:xfrm>
+            <a:off x="5120640" y="1463040"/>
+            <a:ext cx="3931920" cy="457200"/>
+          </a:xfrm>
+          <a:prstGeom prst="rect">
+            <a:avLst/>
+          </a:prstGeom>
+          <a:noFill/>
+          <a:ln/>
+        </p:spPr>
+        <p:txBody>
+          <a:bodyPr wrap="square" rtlCol="0" anchor="ctr"/>
+          <a:lstStyle/>
+          <a:p>
+            <a:pPr algn="ctr" indent="0" marL="0">
+              <a:buNone/>
+            </a:pPr>
+            <a:r>
+              <a:rPr lang="en-US" sz="1300" b="1" dirty="0">
+                <a:solidFill>
+                  <a:srgbClr val="FFFFFF"/>
+                </a:solidFill>
+              </a:rPr>
+              <a:t>5. Prospectus Prep</a:t>
+            </a:r>
+            <a:endParaRPr lang="en-US" sz="1300" dirty="0"/>
+          </a:p>
+        </p:txBody>
+      </p:sp>
+      <p:sp>
+        <p:nvSpPr>
+          <p:cNvPr id="13" name="Shape 11"/>
+          <p:cNvSpPr/>
+          <p:nvPr/>
+        </p:nvSpPr>
+        <p:spPr>
+          <a:xfrm>
+            <a:off x="5120640" y="2057400"/>
+            <a:ext cx="3931920" cy="457200"/>
+          </a:xfrm>
+          <a:prstGeom prst="rect">
+            <a:avLst/>
+          </a:prstGeom>
+          <a:solidFill>
+            <a:srgbClr val="1E2761"/>
+          </a:solidFill>
+          <a:ln/>
+        </p:spPr>
+      </p:sp>
+      <p:sp>
+        <p:nvSpPr>
+          <p:cNvPr id="14" name="Text 12"/>
+          <p:cNvSpPr/>
+          <p:nvPr/>
+        </p:nvSpPr>
+        <p:spPr>
+          <a:xfrm>
+            <a:off x="5120640" y="2057400"/>
+            <a:ext cx="3931920" cy="457200"/>
+          </a:xfrm>
+          <a:prstGeom prst="rect">
+            <a:avLst/>
+          </a:prstGeom>
+          <a:noFill/>
+          <a:ln/>
+        </p:spPr>
+        <p:txBody>
+          <a:bodyPr wrap="square" rtlCol="0" anchor="ctr"/>
+          <a:lstStyle/>
+          <a:p>
+            <a:pPr algn="ctr" indent="0" marL="0">
+              <a:buNone/>
+            </a:pPr>
+            <a:r>
+              <a:rPr lang="en-US" sz="1300" b="1" dirty="0">
+                <a:solidFill>
+                  <a:srgbClr val="FFFFFF"/>
+                </a:solidFill>
+              </a:rPr>
+              <a:t>6. Roadshow</a:t>
+            </a:r>
+            <a:endParaRPr lang="en-US" sz="1300" dirty="0"/>
+          </a:p>
+        </p:txBody>
+      </p:sp>
+      <p:sp>
+        <p:nvSpPr>
+          <p:cNvPr id="15" name="Shape 13"/>
+          <p:cNvSpPr/>
+          <p:nvPr/>
+        </p:nvSpPr>
+        <p:spPr>
+          <a:xfrm>
+            <a:off x="5120640" y="2651760"/>
+            <a:ext cx="3931920" cy="457200"/>
+          </a:xfrm>
+          <a:prstGeom prst="rect">
+            <a:avLst/>
+          </a:prstGeom>
+          <a:solidFill>
+            <a:srgbClr val="F96167"/>
+          </a:solidFill>
+          <a:ln/>
+        </p:spPr>
+      </p:sp>
+      <p:sp>
+        <p:nvSpPr>
+          <p:cNvPr id="16" name="Text 14"/>
+          <p:cNvSpPr/>
+          <p:nvPr/>
+        </p:nvSpPr>
+        <p:spPr>
+          <a:xfrm>
+            <a:off x="5120640" y="2651760"/>
+            <a:ext cx="3931920" cy="457200"/>
+          </a:xfrm>
+          <a:prstGeom prst="rect">
+            <a:avLst/>
+          </a:prstGeom>
+          <a:noFill/>
+          <a:ln/>
+        </p:spPr>
+        <p:txBody>
+          <a:bodyPr wrap="square" rtlCol="0" anchor="ctr"/>
+          <a:lstStyle/>
+          <a:p>
+            <a:pPr algn="ctr" indent="0" marL="0">
+              <a:buNone/>
+            </a:pPr>
+            <a:r>
+              <a:rPr lang="en-US" sz="1300" b="1" dirty="0">
+                <a:solidFill>
+                  <a:srgbClr val="FFFFFF"/>
+                </a:solidFill>
+              </a:rPr>
+              <a:t>7. Regulatory Filing</a:t>
+            </a:r>
+            <a:endParaRPr lang="en-US" sz="1300" dirty="0"/>
+          </a:p>
+        </p:txBody>
+      </p:sp>
+      <p:sp>
+        <p:nvSpPr>
+          <p:cNvPr id="17" name="Shape 15"/>
+          <p:cNvSpPr/>
+          <p:nvPr/>
+        </p:nvSpPr>
+        <p:spPr>
+          <a:xfrm>
+            <a:off x="5120640" y="3246120"/>
+            <a:ext cx="3931920" cy="457200"/>
+          </a:xfrm>
+          <a:prstGeom prst="rect">
+            <a:avLst/>
+          </a:prstGeom>
+          <a:solidFill>
+            <a:srgbClr val="1E2761"/>
+          </a:solidFill>
+          <a:ln/>
+        </p:spPr>
+      </p:sp>
+      <p:sp>
+        <p:nvSpPr>
+          <p:cNvPr id="18" name="Text 16"/>
+          <p:cNvSpPr/>
+          <p:nvPr/>
+        </p:nvSpPr>
+        <p:spPr>
+          <a:xfrm>
+            <a:off x="5120640" y="3246120"/>
+            <a:ext cx="3931920" cy="457200"/>
+          </a:xfrm>
+          <a:prstGeom prst="rect">
+            <a:avLst/>
+          </a:prstGeom>
+          <a:noFill/>
+          <a:ln/>
+        </p:spPr>
+        <p:txBody>
+          <a:bodyPr wrap="square" rtlCol="0" anchor="ctr"/>
+          <a:lstStyle/>
+          <a:p>
+            <a:pPr algn="ctr" indent="0" marL="0">
+              <a:buNone/>
+            </a:pPr>
+            <a:r>
+              <a:rPr lang="en-US" sz="1300" b="1" dirty="0">
+                <a:solidFill>
+                  <a:srgbClr val="FFFFFF"/>
+                </a:solidFill>
+              </a:rPr>
+              <a:t>8. Trading</a:t>
+            </a:r>
+            <a:endParaRPr lang="en-US" sz="1300" dirty="0"/>
+          </a:p>
+        </p:txBody>
+      </p:sp>
+      <p:sp>
+        <p:nvSpPr>
+          <p:cNvPr id="19" name="Text 17"/>
+          <p:cNvSpPr/>
+          <p:nvPr/>
+        </p:nvSpPr>
+        <p:spPr>
+          <a:xfrm>
+            <a:off x="457200" y="457200"/>
+            <a:ext cx="8842248" cy="640080"/>
+          </a:xfrm>
+          <a:prstGeom prst="rect">
+            <a:avLst/>
+          </a:prstGeom>
+          <a:noFill/>
+          <a:ln/>
+        </p:spPr>
+        <p:txBody>
+          <a:bodyPr wrap="square" rtlCol="0" anchor="ctr"/>
+          <a:lstStyle/>
+          <a:p>
+            <a:pPr algn="ctr" indent="0" marL="0">
+              <a:buNone/>
+            </a:pPr>
+            <a:r>
+              <a:rPr lang="en-US" sz="4200" b="1" dirty="0">
+                <a:solidFill>
+                  <a:srgbClr val="1E2761"/>
+                </a:solidFill>
+              </a:rPr>
+              <a:t>From Day 1 to IPO Day</a:t>
+            </a:r>
+            <a:endParaRPr lang="en-US" sz="4200" dirty="0"/>
+          </a:p>
+        </p:txBody>
+      </p:sp>
+      <p:sp>
+        <p:nvSpPr>
+          <p:cNvPr id="20" name="Shape 18"/>
+          <p:cNvSpPr/>
+          <p:nvPr/>
+        </p:nvSpPr>
+        <p:spPr>
+          <a:xfrm>
+            <a:off x="5120640" y="1463040"/>
+            <a:ext cx="3931920" cy="457200"/>
+          </a:xfrm>
+          <a:prstGeom prst="rect">
+            <a:avLst/>
+          </a:prstGeom>
+          <a:solidFill>
+            <a:srgbClr val="F96167"/>
+          </a:solidFill>
+          <a:ln/>
+        </p:spPr>
+      </p:sp>
+      <p:sp>
+        <p:nvSpPr>
+          <p:cNvPr id="21" name="Text 19"/>
+          <p:cNvSpPr/>
+          <p:nvPr/>
+        </p:nvSpPr>
+        <p:spPr>
+          <a:xfrm>
+            <a:off x="5120640" y="1463040"/>
+            <a:ext cx="3931920" cy="457200"/>
+          </a:xfrm>
+          <a:prstGeom prst="rect">
+            <a:avLst/>
+          </a:prstGeom>
+          <a:noFill/>
+          <a:ln/>
+        </p:spPr>
+        <p:txBody>
+          <a:bodyPr wrap="square" rtlCol="0" anchor="ctr"/>
+          <a:lstStyle/>
+          <a:p>
+            <a:pPr algn="ctr" indent="0" marL="0">
+              <a:buNone/>
+            </a:pPr>
+            <a:r>
+              <a:rPr lang="en-US" sz="1300" b="1" dirty="0">
+                <a:solidFill>
+                  <a:srgbClr val="FFFFFF"/>
+                </a:solidFill>
+              </a:rPr>
+              <a:t>1. Governance</a:t>
+            </a:r>
+            <a:endParaRPr lang="en-US" sz="1300" dirty="0"/>
+          </a:p>
+        </p:txBody>
+      </p:sp>
+      <p:sp>
+        <p:nvSpPr>
+          <p:cNvPr id="22" name="Shape 20"/>
+          <p:cNvSpPr/>
+          <p:nvPr/>
+        </p:nvSpPr>
+        <p:spPr>
+          <a:xfrm>
+            <a:off x="5120640" y="2057400"/>
+            <a:ext cx="3931920" cy="457200"/>
+          </a:xfrm>
+          <a:prstGeom prst="rect">
+            <a:avLst/>
+          </a:prstGeom>
+          <a:solidFill>
+            <a:srgbClr val="1E2761"/>
+          </a:solidFill>
+          <a:ln/>
+        </p:spPr>
+      </p:sp>
+      <p:sp>
+        <p:nvSpPr>
+          <p:cNvPr id="23" name="Text 21"/>
+          <p:cNvSpPr/>
+          <p:nvPr/>
+        </p:nvSpPr>
+        <p:spPr>
+          <a:xfrm>
+            <a:off x="5120640" y="2057400"/>
+            <a:ext cx="3931920" cy="457200"/>
+          </a:xfrm>
+          <a:prstGeom prst="rect">
+            <a:avLst/>
+          </a:prstGeom>
+          <a:noFill/>
+          <a:ln/>
+        </p:spPr>
+        <p:txBody>
+          <a:bodyPr wrap="square" rtlCol="0" anchor="ctr"/>
+          <a:lstStyle/>
+          <a:p>
+            <a:pPr algn="ctr" indent="0" marL="0">
+              <a:buNone/>
+            </a:pPr>
+            <a:r>
+              <a:rPr lang="en-US" sz="1300" b="1" dirty="0">
+                <a:solidFill>
+                  <a:srgbClr val="FFFFFF"/>
+                </a:solidFill>
+              </a:rPr>
+              <a:t>2. Financial Audit</a:t>
+            </a:r>
+            <a:endParaRPr lang="en-US" sz="1300" dirty="0"/>
+          </a:p>
+        </p:txBody>
+      </p:sp>
+      <p:sp>
+        <p:nvSpPr>
+          <p:cNvPr id="24" name="Shape 22"/>
+          <p:cNvSpPr/>
+          <p:nvPr/>
+        </p:nvSpPr>
+        <p:spPr>
+          <a:xfrm>
+            <a:off x="5120640" y="2651760"/>
+            <a:ext cx="3931920" cy="457200"/>
+          </a:xfrm>
+          <a:prstGeom prst="rect">
+            <a:avLst/>
+          </a:prstGeom>
+          <a:solidFill>
+            <a:srgbClr val="F96167"/>
+          </a:solidFill>
+          <a:ln/>
+        </p:spPr>
+      </p:sp>
+      <p:sp>
+        <p:nvSpPr>
+          <p:cNvPr id="25" name="Text 23"/>
+          <p:cNvSpPr/>
+          <p:nvPr/>
+        </p:nvSpPr>
+        <p:spPr>
+          <a:xfrm>
+            <a:off x="5120640" y="2651760"/>
+            <a:ext cx="3931920" cy="457200"/>
+          </a:xfrm>
+          <a:prstGeom prst="rect">
+            <a:avLst/>
+          </a:prstGeom>
+          <a:noFill/>
+          <a:ln/>
+        </p:spPr>
+        <p:txBody>
+          <a:bodyPr wrap="square" rtlCol="0" anchor="ctr"/>
+          <a:lstStyle/>
+          <a:p>
+            <a:pPr algn="ctr" indent="0" marL="0">
+              <a:buNone/>
+            </a:pPr>
+            <a:r>
+              <a:rPr lang="en-US" sz="1300" b="1" dirty="0">
+                <a:solidFill>
+                  <a:srgbClr val="FFFFFF"/>
+                </a:solidFill>
+              </a:rPr>
+              <a:t>3. Legal Documentation</a:t>
+            </a:r>
+            <a:endParaRPr lang="en-US" sz="1300" dirty="0"/>
+          </a:p>
+        </p:txBody>
+      </p:sp>
+      <p:sp>
+        <p:nvSpPr>
+          <p:cNvPr id="26" name="Shape 24"/>
+          <p:cNvSpPr/>
+          <p:nvPr/>
+        </p:nvSpPr>
+        <p:spPr>
+          <a:xfrm>
+            <a:off x="5120640" y="3246120"/>
+            <a:ext cx="3931920" cy="457200"/>
+          </a:xfrm>
+          <a:prstGeom prst="rect">
+            <a:avLst/>
+          </a:prstGeom>
+          <a:solidFill>
+            <a:srgbClr val="1E2761"/>
+          </a:solidFill>
+          <a:ln/>
+        </p:spPr>
+      </p:sp>
+      <p:sp>
+        <p:nvSpPr>
+          <p:cNvPr id="27" name="Text 25"/>
+          <p:cNvSpPr/>
+          <p:nvPr/>
+        </p:nvSpPr>
+        <p:spPr>
+          <a:xfrm>
+            <a:off x="5120640" y="3246120"/>
+            <a:ext cx="3931920" cy="457200"/>
+          </a:xfrm>
+          <a:prstGeom prst="rect">
+            <a:avLst/>
+          </a:prstGeom>
+          <a:noFill/>
+          <a:ln/>
+        </p:spPr>
+        <p:txBody>
+          <a:bodyPr wrap="square" rtlCol="0" anchor="ctr"/>
+          <a:lstStyle/>
+          <a:p>
+            <a:pPr algn="ctr" indent="0" marL="0">
+              <a:buNone/>
+            </a:pPr>
+            <a:r>
+              <a:rPr lang="en-US" sz="1300" b="1" dirty="0">
+                <a:solidFill>
+                  <a:srgbClr val="FFFFFF"/>
+                </a:solidFill>
+              </a:rPr>
+              <a:t>4. Compliance Review</a:t>
+            </a:r>
+            <a:endParaRPr lang="en-US" sz="1300" dirty="0"/>
+          </a:p>
+        </p:txBody>
+      </p:sp>
+      <p:sp>
+        <p:nvSpPr>
+          <p:cNvPr id="28" name="Shape 26"/>
+          <p:cNvSpPr/>
+          <p:nvPr/>
+        </p:nvSpPr>
+        <p:spPr>
+          <a:xfrm>
+            <a:off x="9509760" y="1463040"/>
+            <a:ext cx="3931920" cy="457200"/>
+          </a:xfrm>
+          <a:prstGeom prst="rect">
+            <a:avLst/>
+          </a:prstGeom>
+          <a:solidFill>
+            <a:srgbClr val="F96167"/>
+          </a:solidFill>
+          <a:ln/>
+        </p:spPr>
+      </p:sp>
+      <p:sp>
+        <p:nvSpPr>
+          <p:cNvPr id="29" name="Text 27"/>
+          <p:cNvSpPr/>
+          <p:nvPr/>
+        </p:nvSpPr>
+        <p:spPr>
+          <a:xfrm>
+            <a:off x="9509760" y="1463040"/>
+            <a:ext cx="3931920" cy="457200"/>
+          </a:xfrm>
+          <a:prstGeom prst="rect">
+            <a:avLst/>
+          </a:prstGeom>
+          <a:noFill/>
+          <a:ln/>
+        </p:spPr>
+        <p:txBody>
+          <a:bodyPr wrap="square" rtlCol="0" anchor="ctr"/>
+          <a:lstStyle/>
+          <a:p>
+            <a:pPr algn="ctr" indent="0" marL="0">
+              <a:buNone/>
+            </a:pPr>
+            <a:r>
+              <a:rPr lang="en-US" sz="1300" b="1" dirty="0">
+                <a:solidFill>
+                  <a:srgbClr val="FFFFFF"/>
+                </a:solidFill>
+              </a:rPr>
+              <a:t>5. Prospectus Prep</a:t>
+            </a:r>
+            <a:endParaRPr lang="en-US" sz="1300" dirty="0"/>
+          </a:p>
+        </p:txBody>
+      </p:sp>
+      <p:sp>
+        <p:nvSpPr>
+          <p:cNvPr id="30" name="Shape 28"/>
+          <p:cNvSpPr/>
+          <p:nvPr/>
+        </p:nvSpPr>
+        <p:spPr>
+          <a:xfrm>
+            <a:off x="9509760" y="2057400"/>
+            <a:ext cx="3931920" cy="457200"/>
+          </a:xfrm>
+          <a:prstGeom prst="rect">
+            <a:avLst/>
+          </a:prstGeom>
+          <a:solidFill>
+            <a:srgbClr val="1E2761"/>
+          </a:solidFill>
+          <a:ln/>
+        </p:spPr>
+      </p:sp>
+      <p:sp>
+        <p:nvSpPr>
+          <p:cNvPr id="31" name="Text 29"/>
+          <p:cNvSpPr/>
+          <p:nvPr/>
+        </p:nvSpPr>
+        <p:spPr>
+          <a:xfrm>
+            <a:off x="9509760" y="2057400"/>
+            <a:ext cx="3931920" cy="457200"/>
+          </a:xfrm>
+          <a:prstGeom prst="rect">
+            <a:avLst/>
+          </a:prstGeom>
+          <a:noFill/>
+          <a:ln/>
+        </p:spPr>
+        <p:txBody>
+          <a:bodyPr wrap="square" rtlCol="0" anchor="ctr"/>
+          <a:lstStyle/>
+          <a:p>
+            <a:pPr algn="ctr" indent="0" marL="0">
+              <a:buNone/>
+            </a:pPr>
+            <a:r>
+              <a:rPr lang="en-US" sz="1300" b="1" dirty="0">
+                <a:solidFill>
+                  <a:srgbClr val="FFFFFF"/>
+                </a:solidFill>
+              </a:rPr>
+              <a:t>6. Roadshow</a:t>
+            </a:r>
+            <a:endParaRPr lang="en-US" sz="1300" dirty="0"/>
+          </a:p>
+        </p:txBody>
+      </p:sp>
+      <p:sp>
+        <p:nvSpPr>
+          <p:cNvPr id="32" name="Shape 30"/>
+          <p:cNvSpPr/>
+          <p:nvPr/>
+        </p:nvSpPr>
+        <p:spPr>
+          <a:xfrm>
+            <a:off x="9509760" y="2651760"/>
+            <a:ext cx="3931920" cy="457200"/>
+          </a:xfrm>
+          <a:prstGeom prst="rect">
+            <a:avLst/>
+          </a:prstGeom>
+          <a:solidFill>
+            <a:srgbClr val="F96167"/>
+          </a:solidFill>
+          <a:ln/>
+        </p:spPr>
+      </p:sp>
+      <p:sp>
+        <p:nvSpPr>
+          <p:cNvPr id="33" name="Text 31"/>
+          <p:cNvSpPr/>
+          <p:nvPr/>
+        </p:nvSpPr>
+        <p:spPr>
+          <a:xfrm>
+            <a:off x="9509760" y="2651760"/>
+            <a:ext cx="3931920" cy="457200"/>
+          </a:xfrm>
+          <a:prstGeom prst="rect">
+            <a:avLst/>
+          </a:prstGeom>
+          <a:noFill/>
+          <a:ln/>
+        </p:spPr>
+        <p:txBody>
+          <a:bodyPr wrap="square" rtlCol="0" anchor="ctr"/>
+          <a:lstStyle/>
+          <a:p>
+            <a:pPr algn="ctr" indent="0" marL="0">
+              <a:buNone/>
+            </a:pPr>
+            <a:r>
+              <a:rPr lang="en-US" sz="1300" b="1" dirty="0">
+                <a:solidFill>
+                  <a:srgbClr val="FFFFFF"/>
+                </a:solidFill>
+              </a:rPr>
+              <a:t>7. Regulatory Filing</a:t>
+            </a:r>
+            <a:endParaRPr lang="en-US" sz="1300" dirty="0"/>
+          </a:p>
+        </p:txBody>
+      </p:sp>
+      <p:sp>
+        <p:nvSpPr>
+          <p:cNvPr id="34" name="Shape 32"/>
+          <p:cNvSpPr/>
+          <p:nvPr/>
+        </p:nvSpPr>
+        <p:spPr>
+          <a:xfrm>
+            <a:off x="9509760" y="3246120"/>
+            <a:ext cx="3931920" cy="457200"/>
+          </a:xfrm>
+          <a:prstGeom prst="rect">
+            <a:avLst/>
+          </a:prstGeom>
+          <a:solidFill>
+            <a:srgbClr val="1E2761"/>
+          </a:solidFill>
+          <a:ln/>
+        </p:spPr>
+      </p:sp>
+      <p:sp>
+        <p:nvSpPr>
+          <p:cNvPr id="35" name="Text 33"/>
+          <p:cNvSpPr/>
+          <p:nvPr/>
+        </p:nvSpPr>
+        <p:spPr>
+          <a:xfrm>
+            <a:off x="9509760" y="3246120"/>
+            <a:ext cx="3931920" cy="457200"/>
+          </a:xfrm>
+          <a:prstGeom prst="rect">
+            <a:avLst/>
+          </a:prstGeom>
+          <a:noFill/>
+          <a:ln/>
+        </p:spPr>
+        <p:txBody>
+          <a:bodyPr wrap="square" rtlCol="0" anchor="ctr"/>
+          <a:lstStyle/>
+          <a:p>
+            <a:pPr algn="ctr" indent="0" marL="0">
+              <a:buNone/>
+            </a:pPr>
+            <a:r>
+              <a:rPr lang="en-US" sz="1300" b="1" dirty="0">
+                <a:solidFill>
+                  <a:srgbClr val="FFFFFF"/>
+                </a:solidFill>
+              </a:rPr>
+              <a:t>8. Trading</a:t>
+            </a:r>
+            <a:endParaRPr lang="en-US" sz="1300" dirty="0"/>
           </a:p>
         </p:txBody>
       </p:sp>
@@ -1996,13 +4080,13 @@
 </p:sld>
 </file>
 
-<file path=ppt/slides/slide6.xml><?xml version="1.0" encoding="utf-8"?>
+<file path=ppt/slides/slide5.xml><?xml version="1.0" encoding="utf-8"?>
 <p:sld xmlns:a="http://schemas.openxmlformats.org/drawingml/2006/main" xmlns:r="http://schemas.openxmlformats.org/officeDocument/2006/relationships" xmlns:p="http://schemas.openxmlformats.org/presentationml/2006/main">
-  <p:cSld name="Slide 6">
+  <p:cSld name="Slide 5">
     <p:bg>
       <p:bgPr>
         <a:solidFill>
-          <a:srgbClr val="2C5F2D"/>
+          <a:srgbClr val="36454F"/>
         </a:solidFill>
       </p:bgPr>
     </p:bg>
@@ -2028,29 +4112,565 @@
         </p:nvSpPr>
         <p:spPr>
           <a:xfrm>
-            <a:off x="4114800" y="274320"/>
-            <a:ext cx="914400" cy="548640"/>
-          </a:xfrm>
-          <a:prstGeom prst="rect">
-            <a:avLst/>
-          </a:prstGeom>
-          <a:noFill/>
-          <a:ln/>
-        </p:spPr>
-        <p:txBody>
-          <a:bodyPr wrap="square" rtlCol="0" anchor="ctr"/>
-          <a:lstStyle/>
-          <a:p>
-            <a:pPr algn="ctr" indent="0" marL="0">
-              <a:buNone/>
-            </a:pPr>
-            <a:r>
-              <a:rPr lang="en-US" sz="4800" dirty="0">
-                <a:solidFill>
-                  <a:srgbClr val="000000"/>
-                </a:solidFill>
-              </a:rPr>
-              <a:t>✨</a:t>
+            <a:off x="457200" y="457200"/>
+            <a:ext cx="8842248" cy="640080"/>
+          </a:xfrm>
+          <a:prstGeom prst="rect">
+            <a:avLst/>
+          </a:prstGeom>
+          <a:noFill/>
+          <a:ln/>
+        </p:spPr>
+        <p:txBody>
+          <a:bodyPr wrap="square" rtlCol="0" anchor="ctr"/>
+          <a:lstStyle/>
+          <a:p>
+            <a:pPr algn="ctr" indent="0" marL="0">
+              <a:buNone/>
+            </a:pPr>
+            <a:r>
+              <a:rPr lang="en-US" sz="4400" b="1" dirty="0">
+                <a:solidFill>
+                  <a:srgbClr val="FFFFFF"/>
+                </a:solidFill>
+              </a:rPr>
+              <a:t>Is Your Team Ready?</a:t>
+            </a:r>
+            <a:endParaRPr lang="en-US" sz="4400" dirty="0"/>
+          </a:p>
+        </p:txBody>
+      </p:sp>
+      <p:sp>
+        <p:nvSpPr>
+          <p:cNvPr id="3" name="Text 1"/>
+          <p:cNvSpPr/>
+          <p:nvPr/>
+        </p:nvSpPr>
+        <p:spPr>
+          <a:xfrm>
+            <a:off x="1371600" y="1645920"/>
+            <a:ext cx="7013448" cy="457200"/>
+          </a:xfrm>
+          <a:prstGeom prst="rect">
+            <a:avLst/>
+          </a:prstGeom>
+          <a:noFill/>
+          <a:ln/>
+        </p:spPr>
+        <p:txBody>
+          <a:bodyPr wrap="square" rtlCol="0" anchor="ctr"/>
+          <a:lstStyle/>
+          <a:p>
+            <a:pPr algn="l" indent="0" marL="0">
+              <a:buNone/>
+            </a:pPr>
+            <a:r>
+              <a:rPr lang="en-US" sz="1800" dirty="0">
+                <a:solidFill>
+                  <a:srgbClr val="FFFFFF"/>
+                </a:solidFill>
+              </a:rPr>
+              <a:t>✓ CFO &amp; Board assembled</a:t>
+            </a:r>
+            <a:endParaRPr lang="en-US" sz="1800" dirty="0"/>
+          </a:p>
+        </p:txBody>
+      </p:sp>
+      <p:sp>
+        <p:nvSpPr>
+          <p:cNvPr id="4" name="Text 2"/>
+          <p:cNvSpPr/>
+          <p:nvPr/>
+        </p:nvSpPr>
+        <p:spPr>
+          <a:xfrm>
+            <a:off x="1371600" y="2286000"/>
+            <a:ext cx="7013448" cy="457200"/>
+          </a:xfrm>
+          <a:prstGeom prst="rect">
+            <a:avLst/>
+          </a:prstGeom>
+          <a:noFill/>
+          <a:ln/>
+        </p:spPr>
+        <p:txBody>
+          <a:bodyPr wrap="square" rtlCol="0" anchor="ctr"/>
+          <a:lstStyle/>
+          <a:p>
+            <a:pPr algn="l" indent="0" marL="0">
+              <a:buNone/>
+            </a:pPr>
+            <a:r>
+              <a:rPr lang="en-US" sz="1800" dirty="0">
+                <a:solidFill>
+                  <a:srgbClr val="FFFFFF"/>
+                </a:solidFill>
+              </a:rPr>
+              <a:t>✓ Cash runway 12+ months</a:t>
+            </a:r>
+            <a:endParaRPr lang="en-US" sz="1800" dirty="0"/>
+          </a:p>
+        </p:txBody>
+      </p:sp>
+      <p:sp>
+        <p:nvSpPr>
+          <p:cNvPr id="5" name="Text 3"/>
+          <p:cNvSpPr/>
+          <p:nvPr/>
+        </p:nvSpPr>
+        <p:spPr>
+          <a:xfrm>
+            <a:off x="1371600" y="2926080"/>
+            <a:ext cx="7013448" cy="457200"/>
+          </a:xfrm>
+          <a:prstGeom prst="rect">
+            <a:avLst/>
+          </a:prstGeom>
+          <a:noFill/>
+          <a:ln/>
+        </p:spPr>
+        <p:txBody>
+          <a:bodyPr wrap="square" rtlCol="0" anchor="ctr"/>
+          <a:lstStyle/>
+          <a:p>
+            <a:pPr algn="l" indent="0" marL="0">
+              <a:buNone/>
+            </a:pPr>
+            <a:r>
+              <a:rPr lang="en-US" sz="1800" dirty="0">
+                <a:solidFill>
+                  <a:srgbClr val="FFFFFF"/>
+                </a:solidFill>
+              </a:rPr>
+              <a:t>✓ Auditor selected &amp; engaged</a:t>
+            </a:r>
+            <a:endParaRPr lang="en-US" sz="1800" dirty="0"/>
+          </a:p>
+        </p:txBody>
+      </p:sp>
+      <p:sp>
+        <p:nvSpPr>
+          <p:cNvPr id="6" name="Text 4"/>
+          <p:cNvSpPr/>
+          <p:nvPr/>
+        </p:nvSpPr>
+        <p:spPr>
+          <a:xfrm>
+            <a:off x="1371600" y="3566160"/>
+            <a:ext cx="7013448" cy="457200"/>
+          </a:xfrm>
+          <a:prstGeom prst="rect">
+            <a:avLst/>
+          </a:prstGeom>
+          <a:noFill/>
+          <a:ln/>
+        </p:spPr>
+        <p:txBody>
+          <a:bodyPr wrap="square" rtlCol="0" anchor="ctr"/>
+          <a:lstStyle/>
+          <a:p>
+            <a:pPr algn="l" indent="0" marL="0">
+              <a:buNone/>
+            </a:pPr>
+            <a:r>
+              <a:rPr lang="en-US" sz="1800" dirty="0">
+                <a:solidFill>
+                  <a:srgbClr val="FFFFFF"/>
+                </a:solidFill>
+              </a:rPr>
+              <a:t>✓ Cap table cleaned</a:t>
+            </a:r>
+            <a:endParaRPr lang="en-US" sz="1800" dirty="0"/>
+          </a:p>
+        </p:txBody>
+      </p:sp>
+      <p:sp>
+        <p:nvSpPr>
+          <p:cNvPr id="7" name="Text 5"/>
+          <p:cNvSpPr/>
+          <p:nvPr/>
+        </p:nvSpPr>
+        <p:spPr>
+          <a:xfrm>
+            <a:off x="1371600" y="4206240"/>
+            <a:ext cx="7013448" cy="457200"/>
+          </a:xfrm>
+          <a:prstGeom prst="rect">
+            <a:avLst/>
+          </a:prstGeom>
+          <a:noFill/>
+          <a:ln/>
+        </p:spPr>
+        <p:txBody>
+          <a:bodyPr wrap="square" rtlCol="0" anchor="ctr"/>
+          <a:lstStyle/>
+          <a:p>
+            <a:pPr algn="l" indent="0" marL="0">
+              <a:buNone/>
+            </a:pPr>
+            <a:r>
+              <a:rPr lang="en-US" sz="1800" dirty="0">
+                <a:solidFill>
+                  <a:srgbClr val="FFFFFF"/>
+                </a:solidFill>
+              </a:rPr>
+              <a:t>✓ Investor sophistication tracked</a:t>
+            </a:r>
+            <a:endParaRPr lang="en-US" sz="1800" dirty="0"/>
+          </a:p>
+        </p:txBody>
+      </p:sp>
+      <p:sp>
+        <p:nvSpPr>
+          <p:cNvPr id="8" name="Text 6"/>
+          <p:cNvSpPr/>
+          <p:nvPr/>
+        </p:nvSpPr>
+        <p:spPr>
+          <a:xfrm>
+            <a:off x="914400" y="4572000"/>
+            <a:ext cx="7927848" cy="731520"/>
+          </a:xfrm>
+          <a:prstGeom prst="rect">
+            <a:avLst/>
+          </a:prstGeom>
+          <a:noFill/>
+          <a:ln/>
+        </p:spPr>
+        <p:txBody>
+          <a:bodyPr wrap="square" rtlCol="0" anchor="ctr"/>
+          <a:lstStyle/>
+          <a:p>
+            <a:pPr algn="ctr" indent="0" marL="0">
+              <a:buNone/>
+            </a:pPr>
+            <a:r>
+              <a:rPr lang="en-US" sz="1500" i="1" dirty="0">
+                <a:solidFill>
+                  <a:srgbClr val="F9E795"/>
+                </a:solidFill>
+              </a:rPr>
+              <a:t>IPOReady monitors all predictive factors to forecast your IPO timeline with 85% accuracy.</a:t>
+            </a:r>
+            <a:endParaRPr lang="en-US" sz="1500" dirty="0"/>
+          </a:p>
+        </p:txBody>
+      </p:sp>
+      <p:sp>
+        <p:nvSpPr>
+          <p:cNvPr id="9" name="Text 7"/>
+          <p:cNvSpPr/>
+          <p:nvPr/>
+        </p:nvSpPr>
+        <p:spPr>
+          <a:xfrm>
+            <a:off x="457200" y="457200"/>
+            <a:ext cx="8842248" cy="640080"/>
+          </a:xfrm>
+          <a:prstGeom prst="rect">
+            <a:avLst/>
+          </a:prstGeom>
+          <a:noFill/>
+          <a:ln/>
+        </p:spPr>
+        <p:txBody>
+          <a:bodyPr wrap="square" rtlCol="0" anchor="ctr"/>
+          <a:lstStyle/>
+          <a:p>
+            <a:pPr algn="ctr" indent="0" marL="0">
+              <a:buNone/>
+            </a:pPr>
+            <a:r>
+              <a:rPr lang="en-US" sz="4400" b="1" dirty="0">
+                <a:solidFill>
+                  <a:srgbClr val="FFFFFF"/>
+                </a:solidFill>
+              </a:rPr>
+              <a:t>Is Your Team Ready?</a:t>
+            </a:r>
+            <a:endParaRPr lang="en-US" sz="4400" dirty="0"/>
+          </a:p>
+        </p:txBody>
+      </p:sp>
+      <p:sp>
+        <p:nvSpPr>
+          <p:cNvPr id="10" name="Text 8"/>
+          <p:cNvSpPr/>
+          <p:nvPr/>
+        </p:nvSpPr>
+        <p:spPr>
+          <a:xfrm>
+            <a:off x="1371600" y="1645920"/>
+            <a:ext cx="7013448" cy="457200"/>
+          </a:xfrm>
+          <a:prstGeom prst="rect">
+            <a:avLst/>
+          </a:prstGeom>
+          <a:noFill/>
+          <a:ln/>
+        </p:spPr>
+        <p:txBody>
+          <a:bodyPr wrap="square" rtlCol="0" anchor="ctr"/>
+          <a:lstStyle/>
+          <a:p>
+            <a:pPr algn="l" indent="0" marL="0">
+              <a:buNone/>
+            </a:pPr>
+            <a:r>
+              <a:rPr lang="en-US" sz="1800" dirty="0">
+                <a:solidFill>
+                  <a:srgbClr val="FFFFFF"/>
+                </a:solidFill>
+              </a:rPr>
+              <a:t>✓ ✓ CFO &amp; Board assembled</a:t>
+            </a:r>
+            <a:endParaRPr lang="en-US" sz="1800" dirty="0"/>
+          </a:p>
+        </p:txBody>
+      </p:sp>
+      <p:sp>
+        <p:nvSpPr>
+          <p:cNvPr id="11" name="Text 9"/>
+          <p:cNvSpPr/>
+          <p:nvPr/>
+        </p:nvSpPr>
+        <p:spPr>
+          <a:xfrm>
+            <a:off x="1371600" y="2286000"/>
+            <a:ext cx="7013448" cy="457200"/>
+          </a:xfrm>
+          <a:prstGeom prst="rect">
+            <a:avLst/>
+          </a:prstGeom>
+          <a:noFill/>
+          <a:ln/>
+        </p:spPr>
+        <p:txBody>
+          <a:bodyPr wrap="square" rtlCol="0" anchor="ctr"/>
+          <a:lstStyle/>
+          <a:p>
+            <a:pPr algn="l" indent="0" marL="0">
+              <a:buNone/>
+            </a:pPr>
+            <a:r>
+              <a:rPr lang="en-US" sz="1800" dirty="0">
+                <a:solidFill>
+                  <a:srgbClr val="FFFFFF"/>
+                </a:solidFill>
+              </a:rPr>
+              <a:t>✓ ✓ Cash runway 12+ months</a:t>
+            </a:r>
+            <a:endParaRPr lang="en-US" sz="1800" dirty="0"/>
+          </a:p>
+        </p:txBody>
+      </p:sp>
+      <p:sp>
+        <p:nvSpPr>
+          <p:cNvPr id="12" name="Text 10"/>
+          <p:cNvSpPr/>
+          <p:nvPr/>
+        </p:nvSpPr>
+        <p:spPr>
+          <a:xfrm>
+            <a:off x="1371600" y="2926080"/>
+            <a:ext cx="7013448" cy="457200"/>
+          </a:xfrm>
+          <a:prstGeom prst="rect">
+            <a:avLst/>
+          </a:prstGeom>
+          <a:noFill/>
+          <a:ln/>
+        </p:spPr>
+        <p:txBody>
+          <a:bodyPr wrap="square" rtlCol="0" anchor="ctr"/>
+          <a:lstStyle/>
+          <a:p>
+            <a:pPr algn="l" indent="0" marL="0">
+              <a:buNone/>
+            </a:pPr>
+            <a:r>
+              <a:rPr lang="en-US" sz="1800" dirty="0">
+                <a:solidFill>
+                  <a:srgbClr val="FFFFFF"/>
+                </a:solidFill>
+              </a:rPr>
+              <a:t>✓ ✓ Auditor selected &amp; engaged</a:t>
+            </a:r>
+            <a:endParaRPr lang="en-US" sz="1800" dirty="0"/>
+          </a:p>
+        </p:txBody>
+      </p:sp>
+      <p:sp>
+        <p:nvSpPr>
+          <p:cNvPr id="13" name="Text 11"/>
+          <p:cNvSpPr/>
+          <p:nvPr/>
+        </p:nvSpPr>
+        <p:spPr>
+          <a:xfrm>
+            <a:off x="1371600" y="3566160"/>
+            <a:ext cx="7013448" cy="457200"/>
+          </a:xfrm>
+          <a:prstGeom prst="rect">
+            <a:avLst/>
+          </a:prstGeom>
+          <a:noFill/>
+          <a:ln/>
+        </p:spPr>
+        <p:txBody>
+          <a:bodyPr wrap="square" rtlCol="0" anchor="ctr"/>
+          <a:lstStyle/>
+          <a:p>
+            <a:pPr algn="l" indent="0" marL="0">
+              <a:buNone/>
+            </a:pPr>
+            <a:r>
+              <a:rPr lang="en-US" sz="1800" dirty="0">
+                <a:solidFill>
+                  <a:srgbClr val="FFFFFF"/>
+                </a:solidFill>
+              </a:rPr>
+              <a:t>✓ ✓ Cap table cleaned</a:t>
+            </a:r>
+            <a:endParaRPr lang="en-US" sz="1800" dirty="0"/>
+          </a:p>
+        </p:txBody>
+      </p:sp>
+      <p:sp>
+        <p:nvSpPr>
+          <p:cNvPr id="14" name="Text 12"/>
+          <p:cNvSpPr/>
+          <p:nvPr/>
+        </p:nvSpPr>
+        <p:spPr>
+          <a:xfrm>
+            <a:off x="1371600" y="4206240"/>
+            <a:ext cx="7013448" cy="457200"/>
+          </a:xfrm>
+          <a:prstGeom prst="rect">
+            <a:avLst/>
+          </a:prstGeom>
+          <a:noFill/>
+          <a:ln/>
+        </p:spPr>
+        <p:txBody>
+          <a:bodyPr wrap="square" rtlCol="0" anchor="ctr"/>
+          <a:lstStyle/>
+          <a:p>
+            <a:pPr algn="l" indent="0" marL="0">
+              <a:buNone/>
+            </a:pPr>
+            <a:r>
+              <a:rPr lang="en-US" sz="1800" dirty="0">
+                <a:solidFill>
+                  <a:srgbClr val="FFFFFF"/>
+                </a:solidFill>
+              </a:rPr>
+              <a:t>✓ ✓ Investor sophistication tracked</a:t>
+            </a:r>
+            <a:endParaRPr lang="en-US" sz="1800" dirty="0"/>
+          </a:p>
+        </p:txBody>
+      </p:sp>
+      <p:sp>
+        <p:nvSpPr>
+          <p:cNvPr id="15" name="Text 13"/>
+          <p:cNvSpPr/>
+          <p:nvPr/>
+        </p:nvSpPr>
+        <p:spPr>
+          <a:xfrm>
+            <a:off x="914400" y="4572000"/>
+            <a:ext cx="7927848" cy="731520"/>
+          </a:xfrm>
+          <a:prstGeom prst="rect">
+            <a:avLst/>
+          </a:prstGeom>
+          <a:noFill/>
+          <a:ln/>
+        </p:spPr>
+        <p:txBody>
+          <a:bodyPr wrap="square" rtlCol="0" anchor="ctr"/>
+          <a:lstStyle/>
+          <a:p>
+            <a:pPr algn="ctr" indent="0" marL="0">
+              <a:buNone/>
+            </a:pPr>
+            <a:r>
+              <a:rPr lang="en-US" sz="1500" i="1" dirty="0">
+                <a:solidFill>
+                  <a:srgbClr val="F9E795"/>
+                </a:solidFill>
+              </a:rPr>
+              <a:t>IPOReady monitors all predictive factors to forecast your IPO timeline with 85% accuracy.</a:t>
+            </a:r>
+            <a:endParaRPr lang="en-US" sz="1500" dirty="0"/>
+          </a:p>
+        </p:txBody>
+      </p:sp>
+    </p:spTree>
+  </p:cSld>
+  <p:clrMapOvr>
+    <a:masterClrMapping/>
+  </p:clrMapOvr>
+</p:sld>
+</file>
+
+<file path=ppt/slides/slide6.xml><?xml version="1.0" encoding="utf-8"?>
+<p:sld xmlns:a="http://schemas.openxmlformats.org/drawingml/2006/main" xmlns:r="http://schemas.openxmlformats.org/officeDocument/2006/relationships" xmlns:p="http://schemas.openxmlformats.org/presentationml/2006/main">
+  <p:cSld name="Slide 6">
+    <p:bg>
+      <p:bgPr>
+        <a:solidFill>
+          <a:srgbClr val="1E2761"/>
+        </a:solidFill>
+      </p:bgPr>
+    </p:bg>
+    <p:spTree>
+      <p:nvGrpSpPr>
+        <p:cNvPr id="1" name=""/>
+        <p:cNvGrpSpPr/>
+        <p:nvPr/>
+      </p:nvGrpSpPr>
+      <p:grpSpPr>
+        <a:xfrm>
+          <a:off x="0" y="0"/>
+          <a:ext cx="0" cy="0"/>
+          <a:chOff x="0" y="0"/>
+          <a:chExt cx="0" cy="0"/>
+        </a:xfrm>
+      </p:grpSpPr>
+      <p:sp>
+        <p:nvSpPr>
+          <p:cNvPr id="2" name="Text 0"/>
+          <p:cNvSpPr/>
+          <p:nvPr/>
+        </p:nvSpPr>
+        <p:spPr>
+          <a:xfrm>
+            <a:off x="457200" y="1097280"/>
+            <a:ext cx="8842248" cy="731520"/>
+          </a:xfrm>
+          <a:prstGeom prst="rect">
+            <a:avLst/>
+          </a:prstGeom>
+          <a:noFill/>
+          <a:ln/>
+        </p:spPr>
+        <p:txBody>
+          <a:bodyPr wrap="square" rtlCol="0" anchor="ctr"/>
+          <a:lstStyle/>
+          <a:p>
+            <a:pPr algn="ctr" indent="0" marL="0">
+              <a:buNone/>
+            </a:pPr>
+            <a:r>
+              <a:rPr lang="en-US" sz="4800" b="1" dirty="0">
+                <a:solidFill>
+                  <a:srgbClr val="FFFFFF"/>
+                </a:solidFill>
+              </a:rPr>
+              <a:t>Your 14-Day Free Trial Starts Now</a:t>
             </a:r>
             <a:endParaRPr lang="en-US" sz="4800" dirty="0"/>
           </a:p>
@@ -2058,73 +4678,293 @@
       </p:sp>
       <p:sp>
         <p:nvSpPr>
-          <p:cNvPr id="3" name="Text 1"/>
+          <p:cNvPr id="3" name="Shape 1"/>
+          <p:cNvSpPr/>
+          <p:nvPr/>
+        </p:nvSpPr>
+        <p:spPr>
+          <a:xfrm>
+            <a:off x="2286000" y="2194560"/>
+            <a:ext cx="5184648" cy="914400"/>
+          </a:xfrm>
+          <a:prstGeom prst="rect">
+            <a:avLst/>
+          </a:prstGeom>
+          <a:solidFill>
+            <a:srgbClr val="F96167"/>
+          </a:solidFill>
+          <a:ln/>
+        </p:spPr>
+      </p:sp>
+      <p:sp>
+        <p:nvSpPr>
+          <p:cNvPr id="4" name="Text 2"/>
+          <p:cNvSpPr/>
+          <p:nvPr/>
+        </p:nvSpPr>
+        <p:spPr>
+          <a:xfrm>
+            <a:off x="2286000" y="2194560"/>
+            <a:ext cx="5184648" cy="914400"/>
+          </a:xfrm>
+          <a:prstGeom prst="rect">
+            <a:avLst/>
+          </a:prstGeom>
+          <a:noFill/>
+          <a:ln/>
+        </p:spPr>
+        <p:txBody>
+          <a:bodyPr wrap="square" rtlCol="0" anchor="ctr"/>
+          <a:lstStyle/>
+          <a:p>
+            <a:pPr algn="ctr" indent="0" marL="0">
+              <a:buNone/>
+            </a:pPr>
+            <a:r>
+              <a:rPr lang="en-US" sz="2800" b="1" dirty="0">
+                <a:solidFill>
+                  <a:srgbClr val="FFFFFF"/>
+                </a:solidFill>
+              </a:rPr>
+              <a:t>Start Your Free Trial</a:t>
+            </a:r>
+            <a:endParaRPr lang="en-US" sz="2800" dirty="0"/>
+          </a:p>
+        </p:txBody>
+      </p:sp>
+      <p:sp>
+        <p:nvSpPr>
+          <p:cNvPr id="5" name="Text 3"/>
+          <p:cNvSpPr/>
+          <p:nvPr/>
+        </p:nvSpPr>
+        <p:spPr>
+          <a:xfrm>
+            <a:off x="457200" y="3474720"/>
+            <a:ext cx="8842248" cy="457200"/>
+          </a:xfrm>
+          <a:prstGeom prst="rect">
+            <a:avLst/>
+          </a:prstGeom>
+          <a:noFill/>
+          <a:ln/>
+        </p:spPr>
+        <p:txBody>
+          <a:bodyPr wrap="square" rtlCol="0" anchor="ctr"/>
+          <a:lstStyle/>
+          <a:p>
+            <a:pPr algn="ctr" indent="0" marL="0">
+              <a:buNone/>
+            </a:pPr>
+            <a:r>
+              <a:rPr lang="en-US" sz="2000" dirty="0">
+                <a:solidFill>
+                  <a:srgbClr val="F9E795"/>
+                </a:solidFill>
+              </a:rPr>
+              <a:t>ipoready.com/linkedin</a:t>
+            </a:r>
+            <a:endParaRPr lang="en-US" sz="2000" dirty="0"/>
+          </a:p>
+        </p:txBody>
+      </p:sp>
+      <p:sp>
+        <p:nvSpPr>
+          <p:cNvPr id="6" name="Text 4"/>
+          <p:cNvSpPr/>
+          <p:nvPr/>
+        </p:nvSpPr>
+        <p:spPr>
+          <a:xfrm>
+            <a:off x="914400" y="4206240"/>
+            <a:ext cx="7927848" cy="731520"/>
+          </a:xfrm>
+          <a:prstGeom prst="rect">
+            <a:avLst/>
+          </a:prstGeom>
+          <a:noFill/>
+          <a:ln/>
+        </p:spPr>
+        <p:txBody>
+          <a:bodyPr wrap="square" rtlCol="0" anchor="ctr"/>
+          <a:lstStyle/>
+          <a:p>
+            <a:pPr algn="ctr" indent="0" marL="0">
+              <a:buNone/>
+            </a:pPr>
+            <a:r>
+              <a:rPr lang="en-US" sz="1400" dirty="0">
+                <a:solidFill>
+                  <a:srgbClr val="FFFFFF"/>
+                </a:solidFill>
+              </a:rPr>
+              <a:t>No credit card required. Full access to PACE™ scoring and benchmarking for 14 days.</a:t>
+            </a:r>
+            <a:endParaRPr lang="en-US" sz="1400" dirty="0"/>
+          </a:p>
+        </p:txBody>
+      </p:sp>
+      <p:sp>
+        <p:nvSpPr>
+          <p:cNvPr id="7" name="Text 5"/>
           <p:cNvSpPr/>
           <p:nvPr/>
         </p:nvSpPr>
         <p:spPr>
           <a:xfrm>
             <a:off x="457200" y="1097280"/>
-            <a:ext cx="8229600" cy="1645920"/>
-          </a:xfrm>
-          <a:prstGeom prst="rect">
-            <a:avLst/>
-          </a:prstGeom>
-          <a:noFill/>
-          <a:ln/>
-        </p:spPr>
-        <p:txBody>
-          <a:bodyPr wrap="square" rtlCol="0" anchor="t"/>
-          <a:lstStyle/>
-          <a:p>
-            <a:pPr algn="ctr" indent="0" marL="0">
-              <a:buNone/>
-            </a:pPr>
-            <a:r>
-              <a:rPr lang="en-US" sz="3600" b="1" dirty="0">
-                <a:solidFill>
-                  <a:srgbClr val="FFFFFF"/>
-                </a:solidFill>
-              </a:rPr>
-              <a:t>14-Day Free Trial</a:t>
-            </a:r>
-            <a:endParaRPr lang="en-US" sz="3600" dirty="0"/>
-          </a:p>
-        </p:txBody>
-      </p:sp>
-      <p:sp>
-        <p:nvSpPr>
-          <p:cNvPr id="4" name="Text 2"/>
-          <p:cNvSpPr/>
-          <p:nvPr/>
-        </p:nvSpPr>
-        <p:spPr>
-          <a:xfrm>
-            <a:off x="457200" y="10789920"/>
-            <a:ext cx="8229600" cy="365760"/>
-          </a:xfrm>
-          <a:prstGeom prst="rect">
-            <a:avLst/>
-          </a:prstGeom>
-          <a:noFill/>
-          <a:ln/>
-        </p:spPr>
-        <p:txBody>
-          <a:bodyPr wrap="square" rtlCol="0" anchor="ctr"/>
-          <a:lstStyle/>
-          <a:p>
-            <a:pPr algn="ctr" indent="0" marL="0">
-              <a:buNone/>
-            </a:pPr>
-            <a:r>
-              <a:rPr lang="en-US" sz="1100" i="1" dirty="0">
-                <a:solidFill>
-                  <a:srgbClr val="FFFFFF"/>
-                </a:solidFill>
-              </a:rPr>
-              <a:t>LinkedIn Post 6</a:t>
-            </a:r>
-            <a:endParaRPr lang="en-US" sz="1100" dirty="0"/>
+            <a:ext cx="8842248" cy="731520"/>
+          </a:xfrm>
+          <a:prstGeom prst="rect">
+            <a:avLst/>
+          </a:prstGeom>
+          <a:noFill/>
+          <a:ln/>
+        </p:spPr>
+        <p:txBody>
+          <a:bodyPr wrap="square" rtlCol="0" anchor="ctr"/>
+          <a:lstStyle/>
+          <a:p>
+            <a:pPr algn="ctr" indent="0" marL="0">
+              <a:buNone/>
+            </a:pPr>
+            <a:r>
+              <a:rPr lang="en-US" sz="4800" b="1" dirty="0">
+                <a:solidFill>
+                  <a:srgbClr val="FFFFFF"/>
+                </a:solidFill>
+              </a:rPr>
+              <a:t>Your 14-Day Free Trial Starts Now</a:t>
+            </a:r>
+            <a:endParaRPr lang="en-US" sz="4800" dirty="0"/>
+          </a:p>
+        </p:txBody>
+      </p:sp>
+      <p:sp>
+        <p:nvSpPr>
+          <p:cNvPr id="8" name="Shape 6"/>
+          <p:cNvSpPr/>
+          <p:nvPr/>
+        </p:nvSpPr>
+        <p:spPr>
+          <a:xfrm>
+            <a:off x="2286000" y="2194560"/>
+            <a:ext cx="5184648" cy="914400"/>
+          </a:xfrm>
+          <a:prstGeom prst="rect">
+            <a:avLst/>
+          </a:prstGeom>
+          <a:solidFill>
+            <a:srgbClr val="F96167"/>
+          </a:solidFill>
+          <a:ln/>
+        </p:spPr>
+      </p:sp>
+      <p:sp>
+        <p:nvSpPr>
+          <p:cNvPr id="9" name="Text 7"/>
+          <p:cNvSpPr/>
+          <p:nvPr/>
+        </p:nvSpPr>
+        <p:spPr>
+          <a:xfrm>
+            <a:off x="2286000" y="2194560"/>
+            <a:ext cx="5184648" cy="914400"/>
+          </a:xfrm>
+          <a:prstGeom prst="rect">
+            <a:avLst/>
+          </a:prstGeom>
+          <a:noFill/>
+          <a:ln/>
+        </p:spPr>
+        <p:txBody>
+          <a:bodyPr wrap="square" rtlCol="0" anchor="ctr"/>
+          <a:lstStyle/>
+          <a:p>
+            <a:pPr algn="ctr" indent="0" marL="0">
+              <a:buNone/>
+            </a:pPr>
+            <a:r>
+              <a:rPr lang="en-US" sz="2800" b="1" dirty="0">
+                <a:solidFill>
+                  <a:srgbClr val="FFFFFF"/>
+                </a:solidFill>
+              </a:rPr>
+              <a:t>Start Your Free Trial</a:t>
+            </a:r>
+            <a:endParaRPr lang="en-US" sz="2800" dirty="0"/>
+          </a:p>
+        </p:txBody>
+      </p:sp>
+      <p:sp>
+        <p:nvSpPr>
+          <p:cNvPr id="10" name="Text 8"/>
+          <p:cNvSpPr/>
+          <p:nvPr/>
+        </p:nvSpPr>
+        <p:spPr>
+          <a:xfrm>
+            <a:off x="457200" y="3474720"/>
+            <a:ext cx="8842248" cy="457200"/>
+          </a:xfrm>
+          <a:prstGeom prst="rect">
+            <a:avLst/>
+          </a:prstGeom>
+          <a:noFill/>
+          <a:ln/>
+        </p:spPr>
+        <p:txBody>
+          <a:bodyPr wrap="square" rtlCol="0" anchor="ctr"/>
+          <a:lstStyle/>
+          <a:p>
+            <a:pPr algn="ctr" indent="0" marL="0">
+              <a:buNone/>
+            </a:pPr>
+            <a:r>
+              <a:rPr lang="en-US" sz="2000" dirty="0">
+                <a:solidFill>
+                  <a:srgbClr val="F9E795"/>
+                </a:solidFill>
+              </a:rPr>
+              <a:t>ipoready.com/linkedin</a:t>
+            </a:r>
+            <a:endParaRPr lang="en-US" sz="2000" dirty="0"/>
+          </a:p>
+        </p:txBody>
+      </p:sp>
+      <p:sp>
+        <p:nvSpPr>
+          <p:cNvPr id="11" name="Text 9"/>
+          <p:cNvSpPr/>
+          <p:nvPr/>
+        </p:nvSpPr>
+        <p:spPr>
+          <a:xfrm>
+            <a:off x="914400" y="4206240"/>
+            <a:ext cx="7927848" cy="731520"/>
+          </a:xfrm>
+          <a:prstGeom prst="rect">
+            <a:avLst/>
+          </a:prstGeom>
+          <a:noFill/>
+          <a:ln/>
+        </p:spPr>
+        <p:txBody>
+          <a:bodyPr wrap="square" rtlCol="0" anchor="ctr"/>
+          <a:lstStyle/>
+          <a:p>
+            <a:pPr algn="ctr" indent="0" marL="0">
+              <a:buNone/>
+            </a:pPr>
+            <a:r>
+              <a:rPr lang="en-US" sz="1400" dirty="0">
+                <a:solidFill>
+                  <a:srgbClr val="FFFFFF"/>
+                </a:solidFill>
+              </a:rPr>
+              <a:t>No credit card required. Full access to PACE scoring and benchmarking for 14 days.</a:t>
+            </a:r>
+            <a:endParaRPr lang="en-US" sz="1400" dirty="0"/>
           </a:p>
         </p:txBody>
       </p:sp>

</xml_diff>